<commit_message>
Add eXIOME name next to logo and uniform footer across all template slides
Co-Authored-By: Claude Sonnet 5 <noreply@anthropic.com>
Claude-Session: https://claude.ai/code/session_01FgVjCB936DcAgdSaUcb767
</commit_message>
<xml_diff>
--- a/assets/exiome-2026-speaker-template.pptx
+++ b/assets/exiome-2026-speaker-template.pptx
@@ -114,45 +114,45 @@
   <p:extLst>
     <p:ext uri="{521415D9-36F7-43E2-AB2F-B90AF26B5E84}">
       <p14:sectionLst xmlns:p14="http://schemas.microsoft.com/office/powerpoint/2010/main">
-        <p14:section name="Instructions" id="{939df68b-04ae-bf04-d27b-c204d5d22ac8}">
+        <p14:section name="Instructions" id="{f346f4b9-4508-87ec-9df1-7691fcf5cde9}">
           <p14:sldIdLst/>
         </p14:section>
-        <p14:section name="Default-1" id="{80e677f1-2222-7b67-d207-1093d8db7477}">
+        <p14:section name="Default-1" id="{a564d7ff-c566-890a-56b0-b3250325ec77}">
           <p14:sldIdLst>
             <p14:sldId id="256"/>
           </p14:sldIdLst>
         </p14:section>
-        <p14:section name="Title" id="{2f818158-d485-44c5-3201-5694dfdd57e3}">
+        <p14:section name="Title" id="{c0cf977d-a13a-28d4-de48-6b266e70867f}">
           <p14:sldIdLst>
             <p14:sldId id="257"/>
           </p14:sldIdLst>
         </p14:section>
-        <p14:section name="Section Divider" id="{b80291b4-5f64-3870-89b5-4c292617b095}">
+        <p14:section name="Section Divider" id="{28ba3ead-4113-eb58-a50a-c810e21f1d69}">
           <p14:sldIdLst>
             <p14:sldId id="258"/>
           </p14:sldIdLst>
         </p14:section>
-        <p14:section name="Content" id="{605132c3-2c3b-321a-c085-ea1780b534f8}">
+        <p14:section name="Content" id="{1832e4aa-2109-ec4a-f1a4-95c70f0b623b}">
           <p14:sldIdLst>
             <p14:sldId id="259"/>
           </p14:sldIdLst>
         </p14:section>
-        <p14:section name="Content + Image" id="{f844c1c7-84f4-f633-9086-b222f4f3d3b4}">
+        <p14:section name="Content + Image" id="{914708be-8416-197b-0ad7-ccf8906ea1a3}">
           <p14:sldIdLst>
             <p14:sldId id="260"/>
           </p14:sldIdLst>
         </p14:section>
-        <p14:section name="Key Figures" id="{c477ce09-f706-05c9-a657-0e3fc000eeb5}">
+        <p14:section name="Key Figures" id="{79aa37c1-acbc-56a0-b39d-6724d28a99d4}">
           <p14:sldIdLst>
             <p14:sldId id="261"/>
           </p14:sldIdLst>
         </p14:section>
-        <p14:section name="Key Message" id="{c336ae97-86a5-9355-ba6a-715e99046f54}">
+        <p14:section name="Key Message" id="{a1859d23-e0a4-97be-c99a-57d5ae7fd5ce}">
           <p14:sldIdLst>
             <p14:sldId id="262"/>
           </p14:sldIdLst>
         </p14:section>
-        <p14:section name="Closing" id="{0e578cb6-7451-45d0-1979-abac1c5c4077}">
+        <p14:section name="Closing" id="{5ee376b9-8716-4370-c25f-31b2d2ccb70d}">
           <p14:sldIdLst>
             <p14:sldId id="263"/>
           </p14:sldIdLst>
@@ -1305,8 +1305,8 @@
         </p:nvSpPr>
         <p:spPr>
           <a:xfrm>
-            <a:off x="0" y="1874520"/>
-            <a:ext cx="12188952" cy="365760"/>
+            <a:off x="0" y="1627632"/>
+            <a:ext cx="12188952" cy="411480"/>
           </a:xfrm>
           <a:prstGeom prst="rect">
             <a:avLst/>
@@ -1322,9 +1322,48 @@
               <a:buNone/>
             </a:pPr>
             <a:r>
+              <a:rPr lang="en-US" sz="2200" spc="100" kern="0" dirty="0">
+                <a:solidFill>
+                  <a:schemeClr val="accent1"/>
+                </a:solidFill>
+                <a:latin typeface="Cormorant Garamond" pitchFamily="34" charset="0"/>
+                <a:ea typeface="Cormorant Garamond" pitchFamily="34" charset="-122"/>
+                <a:cs typeface="Cormorant Garamond" pitchFamily="34" charset="-120"/>
+              </a:rPr>
+              <a:t>eXIOME 2026</a:t>
+            </a:r>
+            <a:endParaRPr lang="en-US" sz="2200" dirty="0"/>
+          </a:p>
+        </p:txBody>
+      </p:sp>
+      <p:sp>
+        <p:nvSpPr>
+          <p:cNvPr id="4" name="Text 1"/>
+          <p:cNvSpPr/>
+          <p:nvPr/>
+        </p:nvSpPr>
+        <p:spPr>
+          <a:xfrm>
+            <a:off x="0" y="2057400"/>
+            <a:ext cx="12188952" cy="365760"/>
+          </a:xfrm>
+          <a:prstGeom prst="rect">
+            <a:avLst/>
+          </a:prstGeom>
+          <a:noFill/>
+          <a:ln/>
+        </p:spPr>
+        <p:txBody>
+          <a:bodyPr wrap="square" lIns="0" tIns="0" rIns="0" bIns="0" rtlCol="0" anchor="ctr"/>
+          <a:lstStyle/>
+          <a:p>
+            <a:pPr algn="ctr" indent="0" marL="0">
+              <a:buNone/>
+            </a:pPr>
+            <a:r>
               <a:rPr lang="en-US" sz="1100" spc="400" kern="0" dirty="0">
                 <a:solidFill>
-                  <a:schemeClr val="accent1"/>
+                  <a:schemeClr val="accent3"/>
                 </a:solidFill>
                 <a:latin typeface="Montserrat" pitchFamily="34" charset="0"/>
                 <a:ea typeface="Montserrat" pitchFamily="34" charset="-122"/>
@@ -1338,10 +1377,10 @@
       </p:sp>
       <p:sp>
         <p:nvSpPr>
-          <p:cNvPr id="4" name="Text 1"/>
+          <p:cNvPr id="5" name="Text 2"/>
           <p:cNvSpPr/>
           <p:nvPr>
-            <p:ph idx="102" type="title" hasCustomPrompt="1"/>
+            <p:ph idx="103" type="title" hasCustomPrompt="1"/>
           </p:nvPr>
         </p:nvSpPr>
         <p:spPr>
@@ -1391,10 +1430,10 @@
       </p:sp>
       <p:sp>
         <p:nvSpPr>
-          <p:cNvPr id="5" name="Text 1"/>
+          <p:cNvPr id="6" name="Text 2"/>
           <p:cNvSpPr/>
           <p:nvPr>
-            <p:ph idx="103" type="body" hasCustomPrompt="1"/>
+            <p:ph idx="104" type="body" hasCustomPrompt="1"/>
           </p:nvPr>
         </p:nvSpPr>
         <p:spPr>
@@ -1444,14 +1483,14 @@
       </p:sp>
       <p:sp>
         <p:nvSpPr>
-          <p:cNvPr id="6" name="Text 1"/>
+          <p:cNvPr id="7" name="Text 2"/>
           <p:cNvSpPr/>
           <p:nvPr/>
         </p:nvSpPr>
         <p:spPr>
           <a:xfrm>
-            <a:off x="0" y="6035040"/>
-            <a:ext cx="12188952" cy="365760"/>
+            <a:off x="0" y="5852160"/>
+            <a:ext cx="12188952" cy="320040"/>
           </a:xfrm>
           <a:prstGeom prst="rect">
             <a:avLst/>
@@ -1478,6 +1517,117 @@
               <a:t>November 12–14, 2026</a:t>
             </a:r>
             <a:endParaRPr lang="en-US" sz="1100" dirty="0"/>
+          </a:p>
+        </p:txBody>
+      </p:sp>
+      <p:pic>
+        <p:nvPicPr>
+          <p:cNvPr id="8" name="Image 1" descr="/tmp/claude-0/-home-user/75dcd3eb-4c24-536d-ad40-f01cf5d3cf16/scratchpad/pptx-template/logo.png">    </p:cNvPr>
+          <p:cNvPicPr>
+            <a:picLocks noChangeAspect="1"/>
+          </p:cNvPicPr>
+          <p:nvPr/>
+        </p:nvPicPr>
+        <p:blipFill>
+          <a:blip r:embed="rId2"/>
+          <a:stretch>
+            <a:fillRect/>
+          </a:stretch>
+        </p:blipFill>
+        <p:spPr>
+          <a:xfrm>
+            <a:off x="457200" y="6291072"/>
+            <a:ext cx="1005840" cy="390094"/>
+          </a:xfrm>
+          <a:prstGeom prst="rect">
+            <a:avLst/>
+          </a:prstGeom>
+        </p:spPr>
+      </p:pic>
+      <p:sp>
+        <p:nvSpPr>
+          <p:cNvPr id="9" name="Text 3"/>
+          <p:cNvSpPr/>
+          <p:nvPr/>
+        </p:nvSpPr>
+        <p:spPr>
+          <a:xfrm>
+            <a:off x="457200" y="6473952"/>
+            <a:ext cx="3657600" cy="274320"/>
+          </a:xfrm>
+          <a:prstGeom prst="rect">
+            <a:avLst/>
+          </a:prstGeom>
+          <a:noFill/>
+          <a:ln/>
+        </p:spPr>
+        <p:txBody>
+          <a:bodyPr wrap="square" lIns="0" tIns="0" rIns="0" bIns="0" rtlCol="0" anchor="ctr"/>
+          <a:lstStyle/>
+          <a:p>
+            <a:pPr algn="l" indent="0" marL="0">
+              <a:buNone/>
+            </a:pPr>
+            <a:r>
+              <a:rPr lang="en-US" sz="900" spc="200" kern="0" dirty="0">
+                <a:solidFill>
+                  <a:schemeClr val="accent3"/>
+                </a:solidFill>
+                <a:latin typeface="Montserrat" pitchFamily="34" charset="0"/>
+                <a:ea typeface="Montserrat" pitchFamily="34" charset="-122"/>
+                <a:cs typeface="Montserrat" pitchFamily="34" charset="-120"/>
+              </a:rPr>
+              <a:t>eXIOME 2026 · Istanbul</a:t>
+            </a:r>
+            <a:endParaRPr lang="en-US" sz="900" dirty="0"/>
+          </a:p>
+        </p:txBody>
+      </p:sp>
+      <p:sp>
+        <p:nvSpPr>
+          <p:cNvPr id="25" name="Slide Number Placeholder 0"/>
+          <p:cNvSpPr>
+            <a:spLocks noGrp="1"/>
+          </p:cNvSpPr>
+          <p:nvPr>
+            <p:ph type="sldNum" sz="quarter" idx="4294967295"/>
+          </p:nvPr>
+        </p:nvSpPr>
+        <p:spPr>
+          <a:xfrm>
+            <a:off x="11000232" y="6473952"/>
+            <a:ext cx="731520" cy="274320"/>
+          </a:xfrm>
+          <a:prstGeom prst="rect">
+            <a:avLst/>
+          </a:prstGeom>
+          <a:extLst>
+            <a:ext uri="{C572A759-6A51-4108-AA02-DFA0A04FC94B}">
+              <ma14:wrappingTextBoxFlag xmlns:ma14="http://schemas.microsoft.com/office/mac/drawingml/2011/main" val="0"/>
+            </a:ext>
+          </a:extLst>
+        </p:spPr>
+        <p:txBody>
+          <a:bodyPr/>
+          <a:lstStyle>
+            <a:lvl1pPr>
+              <a:defRPr sz="900">
+                <a:solidFill>
+                  <a:schemeClr val="accent3"/>
+                </a:solidFill>
+                <a:latin typeface="Montserrat"/>
+                <a:ea typeface="Montserrat"/>
+                <a:cs typeface="Montserrat"/>
+              </a:defRPr>
+            </a:lvl1pPr>
+          </a:lstStyle>
+          <a:p>
+            <a:pPr algn="r"/>
+            <a:fld id="{F7021451-1387-4CA6-816F-3879F97B5CBC}" type="slidenum">
+              <a:rPr b="0" lang="en-US"/>
+              <a:t>1002</a:t>
+            </a:fld>
+            <a:endParaRPr lang="en-US"/>
           </a:p>
         </p:txBody>
       </p:sp>
@@ -2818,7 +2968,7 @@
         </p:blipFill>
         <p:spPr>
           <a:xfrm>
-            <a:off x="5180076" y="2103120"/>
+            <a:off x="5180076" y="2011680"/>
             <a:ext cx="1828800" cy="709262"/>
           </a:xfrm>
           <a:prstGeom prst="rect">
@@ -2830,13 +2980,52 @@
         <p:nvSpPr>
           <p:cNvPr id="3" name="Text 0"/>
           <p:cNvSpPr/>
-          <p:nvPr>
-            <p:ph idx="101" type="title" hasCustomPrompt="1"/>
-          </p:nvPr>
-        </p:nvSpPr>
-        <p:spPr>
-          <a:xfrm>
-            <a:off x="1097280" y="3108960"/>
+          <p:nvPr/>
+        </p:nvSpPr>
+        <p:spPr>
+          <a:xfrm>
+            <a:off x="0" y="2812382"/>
+            <a:ext cx="12188952" cy="365760"/>
+          </a:xfrm>
+          <a:prstGeom prst="rect">
+            <a:avLst/>
+          </a:prstGeom>
+          <a:noFill/>
+          <a:ln/>
+        </p:spPr>
+        <p:txBody>
+          <a:bodyPr wrap="square" lIns="0" tIns="0" rIns="0" bIns="0" rtlCol="0" anchor="ctr"/>
+          <a:lstStyle/>
+          <a:p>
+            <a:pPr algn="ctr" indent="0" marL="0">
+              <a:buNone/>
+            </a:pPr>
+            <a:r>
+              <a:rPr lang="en-US" sz="2000" spc="100" kern="0" dirty="0">
+                <a:solidFill>
+                  <a:schemeClr val="accent1"/>
+                </a:solidFill>
+                <a:latin typeface="Cormorant Garamond" pitchFamily="34" charset="0"/>
+                <a:ea typeface="Cormorant Garamond" pitchFamily="34" charset="-122"/>
+                <a:cs typeface="Cormorant Garamond" pitchFamily="34" charset="-120"/>
+              </a:rPr>
+              <a:t>eXIOME 2026</a:t>
+            </a:r>
+            <a:endParaRPr lang="en-US" sz="2000" dirty="0"/>
+          </a:p>
+        </p:txBody>
+      </p:sp>
+      <p:sp>
+        <p:nvSpPr>
+          <p:cNvPr id="4" name="Text 1"/>
+          <p:cNvSpPr/>
+          <p:nvPr>
+            <p:ph idx="102" type="title" hasCustomPrompt="1"/>
+          </p:nvPr>
+        </p:nvSpPr>
+        <p:spPr>
+          <a:xfrm>
+            <a:off x="1097280" y="3429000"/>
             <a:ext cx="9994392" cy="914400"/>
           </a:xfrm>
           <a:prstGeom prst="rect">
@@ -2881,15 +3070,15 @@
       </p:sp>
       <p:sp>
         <p:nvSpPr>
-          <p:cNvPr id="4" name="Text 0"/>
+          <p:cNvPr id="5" name="Text 1"/>
           <p:cNvSpPr/>
           <p:nvPr>
-            <p:ph idx="102" type="body" hasCustomPrompt="1"/>
-          </p:nvPr>
-        </p:nvSpPr>
-        <p:spPr>
-          <a:xfrm>
-            <a:off x="1097280" y="4023360"/>
+            <p:ph idx="103" type="body" hasCustomPrompt="1"/>
+          </p:nvPr>
+        </p:nvSpPr>
+        <p:spPr>
+          <a:xfrm>
+            <a:off x="1097280" y="4434840"/>
             <a:ext cx="9994392" cy="548640"/>
           </a:xfrm>
           <a:prstGeom prst="rect">
@@ -2929,6 +3118,117 @@
               <a:t>speaker.name@institution.org</a:t>
             </a:r>
             <a:endParaRPr lang="en-US" sz="1400" dirty="0"/>
+          </a:p>
+        </p:txBody>
+      </p:sp>
+      <p:pic>
+        <p:nvPicPr>
+          <p:cNvPr id="6" name="Image 1" descr="/tmp/claude-0/-home-user/75dcd3eb-4c24-536d-ad40-f01cf5d3cf16/scratchpad/pptx-template/logo.png">    </p:cNvPr>
+          <p:cNvPicPr>
+            <a:picLocks noChangeAspect="1"/>
+          </p:cNvPicPr>
+          <p:nvPr/>
+        </p:nvPicPr>
+        <p:blipFill>
+          <a:blip r:embed="rId2"/>
+          <a:stretch>
+            <a:fillRect/>
+          </a:stretch>
+        </p:blipFill>
+        <p:spPr>
+          <a:xfrm>
+            <a:off x="457200" y="6291072"/>
+            <a:ext cx="1005840" cy="390094"/>
+          </a:xfrm>
+          <a:prstGeom prst="rect">
+            <a:avLst/>
+          </a:prstGeom>
+        </p:spPr>
+      </p:pic>
+      <p:sp>
+        <p:nvSpPr>
+          <p:cNvPr id="7" name="Text 1"/>
+          <p:cNvSpPr/>
+          <p:nvPr/>
+        </p:nvSpPr>
+        <p:spPr>
+          <a:xfrm>
+            <a:off x="457200" y="6473952"/>
+            <a:ext cx="3657600" cy="274320"/>
+          </a:xfrm>
+          <a:prstGeom prst="rect">
+            <a:avLst/>
+          </a:prstGeom>
+          <a:noFill/>
+          <a:ln/>
+        </p:spPr>
+        <p:txBody>
+          <a:bodyPr wrap="square" lIns="0" tIns="0" rIns="0" bIns="0" rtlCol="0" anchor="ctr"/>
+          <a:lstStyle/>
+          <a:p>
+            <a:pPr algn="l" indent="0" marL="0">
+              <a:buNone/>
+            </a:pPr>
+            <a:r>
+              <a:rPr lang="en-US" sz="900" spc="200" kern="0" dirty="0">
+                <a:solidFill>
+                  <a:schemeClr val="accent3"/>
+                </a:solidFill>
+                <a:latin typeface="Montserrat" pitchFamily="34" charset="0"/>
+                <a:ea typeface="Montserrat" pitchFamily="34" charset="-122"/>
+                <a:cs typeface="Montserrat" pitchFamily="34" charset="-120"/>
+              </a:rPr>
+              <a:t>eXIOME 2026 · Istanbul</a:t>
+            </a:r>
+            <a:endParaRPr lang="en-US" sz="900" dirty="0"/>
+          </a:p>
+        </p:txBody>
+      </p:sp>
+      <p:sp>
+        <p:nvSpPr>
+          <p:cNvPr id="25" name="Slide Number Placeholder 0"/>
+          <p:cNvSpPr>
+            <a:spLocks noGrp="1"/>
+          </p:cNvSpPr>
+          <p:nvPr>
+            <p:ph type="sldNum" sz="quarter" idx="4294967295"/>
+          </p:nvPr>
+        </p:nvSpPr>
+        <p:spPr>
+          <a:xfrm>
+            <a:off x="11000232" y="6473952"/>
+            <a:ext cx="731520" cy="274320"/>
+          </a:xfrm>
+          <a:prstGeom prst="rect">
+            <a:avLst/>
+          </a:prstGeom>
+          <a:extLst>
+            <a:ext uri="{C572A759-6A51-4108-AA02-DFA0A04FC94B}">
+              <ma14:wrappingTextBoxFlag xmlns:ma14="http://schemas.microsoft.com/office/mac/drawingml/2011/main" val="0"/>
+            </a:ext>
+          </a:extLst>
+        </p:spPr>
+        <p:txBody>
+          <a:bodyPr/>
+          <a:lstStyle>
+            <a:lvl1pPr>
+              <a:defRPr sz="900">
+                <a:solidFill>
+                  <a:schemeClr val="accent3"/>
+                </a:solidFill>
+                <a:latin typeface="Montserrat"/>
+                <a:ea typeface="Montserrat"/>
+                <a:cs typeface="Montserrat"/>
+              </a:defRPr>
+            </a:lvl1pPr>
+          </a:lstStyle>
+          <a:p>
+            <a:pPr algn="r"/>
+            <a:fld id="{F7021451-1387-4CA6-816F-3879F97B5CBC}" type="slidenum">
+              <a:rPr b="0" lang="en-US"/>
+              <a:t>1008</a:t>
+            </a:fld>
+            <a:endParaRPr lang="en-US"/>
           </a:p>
         </p:txBody>
       </p:sp>
@@ -3534,10 +3834,10 @@
       </p:grpSpPr>
       <p:sp>
         <p:nvSpPr>
-          <p:cNvPr id="2" name="Text 1"/>
+          <p:cNvPr id="2" name="Text 2"/>
           <p:cNvSpPr/>
           <p:nvPr>
-            <p:ph idx="102" type="title" hasCustomPrompt="1"/>
+            <p:ph idx="103" type="title" hasCustomPrompt="1"/>
           </p:nvPr>
         </p:nvSpPr>
         <p:spPr>
@@ -3575,10 +3875,10 @@
       </p:sp>
       <p:sp>
         <p:nvSpPr>
-          <p:cNvPr id="3" name="Text 1"/>
+          <p:cNvPr id="3" name="Text 2"/>
           <p:cNvSpPr/>
           <p:nvPr>
-            <p:ph idx="103" type="body" hasCustomPrompt="1"/>
+            <p:ph idx="104" type="body" hasCustomPrompt="1"/>
           </p:nvPr>
         </p:nvSpPr>
         <p:spPr>
@@ -3611,6 +3911,54 @@
               <a:t>Speaker Name — Institution, City, Country</a:t>
             </a:r>
             <a:endParaRPr lang="en-US" sz="2000" dirty="0"/>
+          </a:p>
+        </p:txBody>
+      </p:sp>
+      <p:sp>
+        <p:nvSpPr>
+          <p:cNvPr id="25" name="Slide Number Placeholder 0"/>
+          <p:cNvSpPr>
+            <a:spLocks noGrp="1"/>
+          </p:cNvSpPr>
+          <p:nvPr>
+            <p:ph type="sldNum" sz="quarter" idx="4294967295"/>
+          </p:nvPr>
+        </p:nvSpPr>
+        <p:spPr>
+          <a:xfrm>
+            <a:off x="11000232" y="6473952"/>
+            <a:ext cx="731520" cy="274320"/>
+          </a:xfrm>
+          <a:prstGeom prst="rect">
+            <a:avLst/>
+          </a:prstGeom>
+          <a:extLst>
+            <a:ext uri="{C572A759-6A51-4108-AA02-DFA0A04FC94B}">
+              <ma14:wrappingTextBoxFlag xmlns:ma14="http://schemas.microsoft.com/office/mac/drawingml/2011/main" val="0"/>
+            </a:ext>
+          </a:extLst>
+        </p:spPr>
+        <p:txBody>
+          <a:bodyPr/>
+          <a:lstStyle>
+            <a:lvl1pPr>
+              <a:defRPr sz="900">
+                <a:solidFill>
+                  <a:schemeClr val="accent3"/>
+                </a:solidFill>
+                <a:latin typeface="Montserrat"/>
+                <a:ea typeface="Montserrat"/>
+                <a:cs typeface="Montserrat"/>
+              </a:defRPr>
+            </a:lvl1pPr>
+          </a:lstStyle>
+          <a:p>
+            <a:pPr algn="r"/>
+            <a:fld id="{F7021451-1387-4CA6-816F-3879F97B5CBC}" type="slidenum">
+              <a:rPr b="0" lang="en-US"/>
+              <a:t>2</a:t>
+            </a:fld>
+            <a:endParaRPr lang="en-US"/>
           </a:p>
         </p:txBody>
       </p:sp>
@@ -4729,15 +5077,15 @@
       </p:grpSpPr>
       <p:sp>
         <p:nvSpPr>
-          <p:cNvPr id="2" name="Text 0"/>
+          <p:cNvPr id="2" name="Text 1"/>
           <p:cNvSpPr/>
           <p:nvPr>
-            <p:ph idx="101" type="title" hasCustomPrompt="1"/>
-          </p:nvPr>
-        </p:nvSpPr>
-        <p:spPr>
-          <a:xfrm>
-            <a:off x="1097280" y="3108960"/>
+            <p:ph idx="102" type="title" hasCustomPrompt="1"/>
+          </p:nvPr>
+        </p:nvSpPr>
+        <p:spPr>
+          <a:xfrm>
+            <a:off x="1097280" y="3429000"/>
             <a:ext cx="9994392" cy="914400"/>
           </a:xfrm>
           <a:prstGeom prst="rect">
@@ -4770,15 +5118,15 @@
       </p:sp>
       <p:sp>
         <p:nvSpPr>
-          <p:cNvPr id="3" name="Text 0"/>
+          <p:cNvPr id="3" name="Text 1"/>
           <p:cNvSpPr/>
           <p:nvPr>
-            <p:ph idx="102" type="body" hasCustomPrompt="1"/>
-          </p:nvPr>
-        </p:nvSpPr>
-        <p:spPr>
-          <a:xfrm>
-            <a:off x="1097280" y="4023360"/>
+            <p:ph idx="103" type="body" hasCustomPrompt="1"/>
+          </p:nvPr>
+        </p:nvSpPr>
+        <p:spPr>
+          <a:xfrm>
+            <a:off x="1097280" y="4434840"/>
             <a:ext cx="9994392" cy="548640"/>
           </a:xfrm>
           <a:prstGeom prst="rect">
@@ -4806,6 +5154,54 @@
               <a:t>your.email@institution.org</a:t>
             </a:r>
             <a:endParaRPr lang="en-US" sz="1400" dirty="0"/>
+          </a:p>
+        </p:txBody>
+      </p:sp>
+      <p:sp>
+        <p:nvSpPr>
+          <p:cNvPr id="25" name="Slide Number Placeholder 0"/>
+          <p:cNvSpPr>
+            <a:spLocks noGrp="1"/>
+          </p:cNvSpPr>
+          <p:nvPr>
+            <p:ph type="sldNum" sz="quarter" idx="4294967295"/>
+          </p:nvPr>
+        </p:nvSpPr>
+        <p:spPr>
+          <a:xfrm>
+            <a:off x="11000232" y="6473952"/>
+            <a:ext cx="731520" cy="274320"/>
+          </a:xfrm>
+          <a:prstGeom prst="rect">
+            <a:avLst/>
+          </a:prstGeom>
+          <a:extLst>
+            <a:ext uri="{C572A759-6A51-4108-AA02-DFA0A04FC94B}">
+              <ma14:wrappingTextBoxFlag xmlns:ma14="http://schemas.microsoft.com/office/mac/drawingml/2011/main" val="0"/>
+            </a:ext>
+          </a:extLst>
+        </p:spPr>
+        <p:txBody>
+          <a:bodyPr/>
+          <a:lstStyle>
+            <a:lvl1pPr>
+              <a:defRPr sz="900">
+                <a:solidFill>
+                  <a:schemeClr val="accent3"/>
+                </a:solidFill>
+                <a:latin typeface="Montserrat"/>
+                <a:ea typeface="Montserrat"/>
+                <a:cs typeface="Montserrat"/>
+              </a:defRPr>
+            </a:lvl1pPr>
+          </a:lstStyle>
+          <a:p>
+            <a:pPr algn="r"/>
+            <a:fld id="{F7021451-1387-4CA6-816F-3879F97B5CBC}" type="slidenum">
+              <a:rPr b="0" lang="en-US"/>
+              <a:t>8</a:t>
+            </a:fld>
+            <a:endParaRPr lang="en-US"/>
           </a:p>
         </p:txBody>
       </p:sp>

</xml_diff>

<commit_message>
Add eXIOME name next to logo and uniform footer across all template slides (#36)
Claude-Session: https://claude.ai/code/session_01FgVjCB936DcAgdSaUcb767

Co-authored-by: Claude <noreply@anthropic.com>
</commit_message>
<xml_diff>
--- a/assets/exiome-2026-speaker-template.pptx
+++ b/assets/exiome-2026-speaker-template.pptx
@@ -114,45 +114,45 @@
   <p:extLst>
     <p:ext uri="{521415D9-36F7-43E2-AB2F-B90AF26B5E84}">
       <p14:sectionLst xmlns:p14="http://schemas.microsoft.com/office/powerpoint/2010/main">
-        <p14:section name="Instructions" id="{939df68b-04ae-bf04-d27b-c204d5d22ac8}">
+        <p14:section name="Instructions" id="{f346f4b9-4508-87ec-9df1-7691fcf5cde9}">
           <p14:sldIdLst/>
         </p14:section>
-        <p14:section name="Default-1" id="{80e677f1-2222-7b67-d207-1093d8db7477}">
+        <p14:section name="Default-1" id="{a564d7ff-c566-890a-56b0-b3250325ec77}">
           <p14:sldIdLst>
             <p14:sldId id="256"/>
           </p14:sldIdLst>
         </p14:section>
-        <p14:section name="Title" id="{2f818158-d485-44c5-3201-5694dfdd57e3}">
+        <p14:section name="Title" id="{c0cf977d-a13a-28d4-de48-6b266e70867f}">
           <p14:sldIdLst>
             <p14:sldId id="257"/>
           </p14:sldIdLst>
         </p14:section>
-        <p14:section name="Section Divider" id="{b80291b4-5f64-3870-89b5-4c292617b095}">
+        <p14:section name="Section Divider" id="{28ba3ead-4113-eb58-a50a-c810e21f1d69}">
           <p14:sldIdLst>
             <p14:sldId id="258"/>
           </p14:sldIdLst>
         </p14:section>
-        <p14:section name="Content" id="{605132c3-2c3b-321a-c085-ea1780b534f8}">
+        <p14:section name="Content" id="{1832e4aa-2109-ec4a-f1a4-95c70f0b623b}">
           <p14:sldIdLst>
             <p14:sldId id="259"/>
           </p14:sldIdLst>
         </p14:section>
-        <p14:section name="Content + Image" id="{f844c1c7-84f4-f633-9086-b222f4f3d3b4}">
+        <p14:section name="Content + Image" id="{914708be-8416-197b-0ad7-ccf8906ea1a3}">
           <p14:sldIdLst>
             <p14:sldId id="260"/>
           </p14:sldIdLst>
         </p14:section>
-        <p14:section name="Key Figures" id="{c477ce09-f706-05c9-a657-0e3fc000eeb5}">
+        <p14:section name="Key Figures" id="{79aa37c1-acbc-56a0-b39d-6724d28a99d4}">
           <p14:sldIdLst>
             <p14:sldId id="261"/>
           </p14:sldIdLst>
         </p14:section>
-        <p14:section name="Key Message" id="{c336ae97-86a5-9355-ba6a-715e99046f54}">
+        <p14:section name="Key Message" id="{a1859d23-e0a4-97be-c99a-57d5ae7fd5ce}">
           <p14:sldIdLst>
             <p14:sldId id="262"/>
           </p14:sldIdLst>
         </p14:section>
-        <p14:section name="Closing" id="{0e578cb6-7451-45d0-1979-abac1c5c4077}">
+        <p14:section name="Closing" id="{5ee376b9-8716-4370-c25f-31b2d2ccb70d}">
           <p14:sldIdLst>
             <p14:sldId id="263"/>
           </p14:sldIdLst>
@@ -1305,8 +1305,8 @@
         </p:nvSpPr>
         <p:spPr>
           <a:xfrm>
-            <a:off x="0" y="1874520"/>
-            <a:ext cx="12188952" cy="365760"/>
+            <a:off x="0" y="1627632"/>
+            <a:ext cx="12188952" cy="411480"/>
           </a:xfrm>
           <a:prstGeom prst="rect">
             <a:avLst/>
@@ -1322,9 +1322,48 @@
               <a:buNone/>
             </a:pPr>
             <a:r>
+              <a:rPr lang="en-US" sz="2200" spc="100" kern="0" dirty="0">
+                <a:solidFill>
+                  <a:schemeClr val="accent1"/>
+                </a:solidFill>
+                <a:latin typeface="Cormorant Garamond" pitchFamily="34" charset="0"/>
+                <a:ea typeface="Cormorant Garamond" pitchFamily="34" charset="-122"/>
+                <a:cs typeface="Cormorant Garamond" pitchFamily="34" charset="-120"/>
+              </a:rPr>
+              <a:t>eXIOME 2026</a:t>
+            </a:r>
+            <a:endParaRPr lang="en-US" sz="2200" dirty="0"/>
+          </a:p>
+        </p:txBody>
+      </p:sp>
+      <p:sp>
+        <p:nvSpPr>
+          <p:cNvPr id="4" name="Text 1"/>
+          <p:cNvSpPr/>
+          <p:nvPr/>
+        </p:nvSpPr>
+        <p:spPr>
+          <a:xfrm>
+            <a:off x="0" y="2057400"/>
+            <a:ext cx="12188952" cy="365760"/>
+          </a:xfrm>
+          <a:prstGeom prst="rect">
+            <a:avLst/>
+          </a:prstGeom>
+          <a:noFill/>
+          <a:ln/>
+        </p:spPr>
+        <p:txBody>
+          <a:bodyPr wrap="square" lIns="0" tIns="0" rIns="0" bIns="0" rtlCol="0" anchor="ctr"/>
+          <a:lstStyle/>
+          <a:p>
+            <a:pPr algn="ctr" indent="0" marL="0">
+              <a:buNone/>
+            </a:pPr>
+            <a:r>
               <a:rPr lang="en-US" sz="1100" spc="400" kern="0" dirty="0">
                 <a:solidFill>
-                  <a:schemeClr val="accent1"/>
+                  <a:schemeClr val="accent3"/>
                 </a:solidFill>
                 <a:latin typeface="Montserrat" pitchFamily="34" charset="0"/>
                 <a:ea typeface="Montserrat" pitchFamily="34" charset="-122"/>
@@ -1338,10 +1377,10 @@
       </p:sp>
       <p:sp>
         <p:nvSpPr>
-          <p:cNvPr id="4" name="Text 1"/>
+          <p:cNvPr id="5" name="Text 2"/>
           <p:cNvSpPr/>
           <p:nvPr>
-            <p:ph idx="102" type="title" hasCustomPrompt="1"/>
+            <p:ph idx="103" type="title" hasCustomPrompt="1"/>
           </p:nvPr>
         </p:nvSpPr>
         <p:spPr>
@@ -1391,10 +1430,10 @@
       </p:sp>
       <p:sp>
         <p:nvSpPr>
-          <p:cNvPr id="5" name="Text 1"/>
+          <p:cNvPr id="6" name="Text 2"/>
           <p:cNvSpPr/>
           <p:nvPr>
-            <p:ph idx="103" type="body" hasCustomPrompt="1"/>
+            <p:ph idx="104" type="body" hasCustomPrompt="1"/>
           </p:nvPr>
         </p:nvSpPr>
         <p:spPr>
@@ -1444,14 +1483,14 @@
       </p:sp>
       <p:sp>
         <p:nvSpPr>
-          <p:cNvPr id="6" name="Text 1"/>
+          <p:cNvPr id="7" name="Text 2"/>
           <p:cNvSpPr/>
           <p:nvPr/>
         </p:nvSpPr>
         <p:spPr>
           <a:xfrm>
-            <a:off x="0" y="6035040"/>
-            <a:ext cx="12188952" cy="365760"/>
+            <a:off x="0" y="5852160"/>
+            <a:ext cx="12188952" cy="320040"/>
           </a:xfrm>
           <a:prstGeom prst="rect">
             <a:avLst/>
@@ -1478,6 +1517,117 @@
               <a:t>November 12–14, 2026</a:t>
             </a:r>
             <a:endParaRPr lang="en-US" sz="1100" dirty="0"/>
+          </a:p>
+        </p:txBody>
+      </p:sp>
+      <p:pic>
+        <p:nvPicPr>
+          <p:cNvPr id="8" name="Image 1" descr="/tmp/claude-0/-home-user/75dcd3eb-4c24-536d-ad40-f01cf5d3cf16/scratchpad/pptx-template/logo.png">    </p:cNvPr>
+          <p:cNvPicPr>
+            <a:picLocks noChangeAspect="1"/>
+          </p:cNvPicPr>
+          <p:nvPr/>
+        </p:nvPicPr>
+        <p:blipFill>
+          <a:blip r:embed="rId2"/>
+          <a:stretch>
+            <a:fillRect/>
+          </a:stretch>
+        </p:blipFill>
+        <p:spPr>
+          <a:xfrm>
+            <a:off x="457200" y="6291072"/>
+            <a:ext cx="1005840" cy="390094"/>
+          </a:xfrm>
+          <a:prstGeom prst="rect">
+            <a:avLst/>
+          </a:prstGeom>
+        </p:spPr>
+      </p:pic>
+      <p:sp>
+        <p:nvSpPr>
+          <p:cNvPr id="9" name="Text 3"/>
+          <p:cNvSpPr/>
+          <p:nvPr/>
+        </p:nvSpPr>
+        <p:spPr>
+          <a:xfrm>
+            <a:off x="457200" y="6473952"/>
+            <a:ext cx="3657600" cy="274320"/>
+          </a:xfrm>
+          <a:prstGeom prst="rect">
+            <a:avLst/>
+          </a:prstGeom>
+          <a:noFill/>
+          <a:ln/>
+        </p:spPr>
+        <p:txBody>
+          <a:bodyPr wrap="square" lIns="0" tIns="0" rIns="0" bIns="0" rtlCol="0" anchor="ctr"/>
+          <a:lstStyle/>
+          <a:p>
+            <a:pPr algn="l" indent="0" marL="0">
+              <a:buNone/>
+            </a:pPr>
+            <a:r>
+              <a:rPr lang="en-US" sz="900" spc="200" kern="0" dirty="0">
+                <a:solidFill>
+                  <a:schemeClr val="accent3"/>
+                </a:solidFill>
+                <a:latin typeface="Montserrat" pitchFamily="34" charset="0"/>
+                <a:ea typeface="Montserrat" pitchFamily="34" charset="-122"/>
+                <a:cs typeface="Montserrat" pitchFamily="34" charset="-120"/>
+              </a:rPr>
+              <a:t>eXIOME 2026 · Istanbul</a:t>
+            </a:r>
+            <a:endParaRPr lang="en-US" sz="900" dirty="0"/>
+          </a:p>
+        </p:txBody>
+      </p:sp>
+      <p:sp>
+        <p:nvSpPr>
+          <p:cNvPr id="25" name="Slide Number Placeholder 0"/>
+          <p:cNvSpPr>
+            <a:spLocks noGrp="1"/>
+          </p:cNvSpPr>
+          <p:nvPr>
+            <p:ph type="sldNum" sz="quarter" idx="4294967295"/>
+          </p:nvPr>
+        </p:nvSpPr>
+        <p:spPr>
+          <a:xfrm>
+            <a:off x="11000232" y="6473952"/>
+            <a:ext cx="731520" cy="274320"/>
+          </a:xfrm>
+          <a:prstGeom prst="rect">
+            <a:avLst/>
+          </a:prstGeom>
+          <a:extLst>
+            <a:ext uri="{C572A759-6A51-4108-AA02-DFA0A04FC94B}">
+              <ma14:wrappingTextBoxFlag xmlns:ma14="http://schemas.microsoft.com/office/mac/drawingml/2011/main" val="0"/>
+            </a:ext>
+          </a:extLst>
+        </p:spPr>
+        <p:txBody>
+          <a:bodyPr/>
+          <a:lstStyle>
+            <a:lvl1pPr>
+              <a:defRPr sz="900">
+                <a:solidFill>
+                  <a:schemeClr val="accent3"/>
+                </a:solidFill>
+                <a:latin typeface="Montserrat"/>
+                <a:ea typeface="Montserrat"/>
+                <a:cs typeface="Montserrat"/>
+              </a:defRPr>
+            </a:lvl1pPr>
+          </a:lstStyle>
+          <a:p>
+            <a:pPr algn="r"/>
+            <a:fld id="{F7021451-1387-4CA6-816F-3879F97B5CBC}" type="slidenum">
+              <a:rPr b="0" lang="en-US"/>
+              <a:t>1002</a:t>
+            </a:fld>
+            <a:endParaRPr lang="en-US"/>
           </a:p>
         </p:txBody>
       </p:sp>
@@ -2818,7 +2968,7 @@
         </p:blipFill>
         <p:spPr>
           <a:xfrm>
-            <a:off x="5180076" y="2103120"/>
+            <a:off x="5180076" y="2011680"/>
             <a:ext cx="1828800" cy="709262"/>
           </a:xfrm>
           <a:prstGeom prst="rect">
@@ -2830,13 +2980,52 @@
         <p:nvSpPr>
           <p:cNvPr id="3" name="Text 0"/>
           <p:cNvSpPr/>
-          <p:nvPr>
-            <p:ph idx="101" type="title" hasCustomPrompt="1"/>
-          </p:nvPr>
-        </p:nvSpPr>
-        <p:spPr>
-          <a:xfrm>
-            <a:off x="1097280" y="3108960"/>
+          <p:nvPr/>
+        </p:nvSpPr>
+        <p:spPr>
+          <a:xfrm>
+            <a:off x="0" y="2812382"/>
+            <a:ext cx="12188952" cy="365760"/>
+          </a:xfrm>
+          <a:prstGeom prst="rect">
+            <a:avLst/>
+          </a:prstGeom>
+          <a:noFill/>
+          <a:ln/>
+        </p:spPr>
+        <p:txBody>
+          <a:bodyPr wrap="square" lIns="0" tIns="0" rIns="0" bIns="0" rtlCol="0" anchor="ctr"/>
+          <a:lstStyle/>
+          <a:p>
+            <a:pPr algn="ctr" indent="0" marL="0">
+              <a:buNone/>
+            </a:pPr>
+            <a:r>
+              <a:rPr lang="en-US" sz="2000" spc="100" kern="0" dirty="0">
+                <a:solidFill>
+                  <a:schemeClr val="accent1"/>
+                </a:solidFill>
+                <a:latin typeface="Cormorant Garamond" pitchFamily="34" charset="0"/>
+                <a:ea typeface="Cormorant Garamond" pitchFamily="34" charset="-122"/>
+                <a:cs typeface="Cormorant Garamond" pitchFamily="34" charset="-120"/>
+              </a:rPr>
+              <a:t>eXIOME 2026</a:t>
+            </a:r>
+            <a:endParaRPr lang="en-US" sz="2000" dirty="0"/>
+          </a:p>
+        </p:txBody>
+      </p:sp>
+      <p:sp>
+        <p:nvSpPr>
+          <p:cNvPr id="4" name="Text 1"/>
+          <p:cNvSpPr/>
+          <p:nvPr>
+            <p:ph idx="102" type="title" hasCustomPrompt="1"/>
+          </p:nvPr>
+        </p:nvSpPr>
+        <p:spPr>
+          <a:xfrm>
+            <a:off x="1097280" y="3429000"/>
             <a:ext cx="9994392" cy="914400"/>
           </a:xfrm>
           <a:prstGeom prst="rect">
@@ -2881,15 +3070,15 @@
       </p:sp>
       <p:sp>
         <p:nvSpPr>
-          <p:cNvPr id="4" name="Text 0"/>
+          <p:cNvPr id="5" name="Text 1"/>
           <p:cNvSpPr/>
           <p:nvPr>
-            <p:ph idx="102" type="body" hasCustomPrompt="1"/>
-          </p:nvPr>
-        </p:nvSpPr>
-        <p:spPr>
-          <a:xfrm>
-            <a:off x="1097280" y="4023360"/>
+            <p:ph idx="103" type="body" hasCustomPrompt="1"/>
+          </p:nvPr>
+        </p:nvSpPr>
+        <p:spPr>
+          <a:xfrm>
+            <a:off x="1097280" y="4434840"/>
             <a:ext cx="9994392" cy="548640"/>
           </a:xfrm>
           <a:prstGeom prst="rect">
@@ -2929,6 +3118,117 @@
               <a:t>speaker.name@institution.org</a:t>
             </a:r>
             <a:endParaRPr lang="en-US" sz="1400" dirty="0"/>
+          </a:p>
+        </p:txBody>
+      </p:sp>
+      <p:pic>
+        <p:nvPicPr>
+          <p:cNvPr id="6" name="Image 1" descr="/tmp/claude-0/-home-user/75dcd3eb-4c24-536d-ad40-f01cf5d3cf16/scratchpad/pptx-template/logo.png">    </p:cNvPr>
+          <p:cNvPicPr>
+            <a:picLocks noChangeAspect="1"/>
+          </p:cNvPicPr>
+          <p:nvPr/>
+        </p:nvPicPr>
+        <p:blipFill>
+          <a:blip r:embed="rId2"/>
+          <a:stretch>
+            <a:fillRect/>
+          </a:stretch>
+        </p:blipFill>
+        <p:spPr>
+          <a:xfrm>
+            <a:off x="457200" y="6291072"/>
+            <a:ext cx="1005840" cy="390094"/>
+          </a:xfrm>
+          <a:prstGeom prst="rect">
+            <a:avLst/>
+          </a:prstGeom>
+        </p:spPr>
+      </p:pic>
+      <p:sp>
+        <p:nvSpPr>
+          <p:cNvPr id="7" name="Text 1"/>
+          <p:cNvSpPr/>
+          <p:nvPr/>
+        </p:nvSpPr>
+        <p:spPr>
+          <a:xfrm>
+            <a:off x="457200" y="6473952"/>
+            <a:ext cx="3657600" cy="274320"/>
+          </a:xfrm>
+          <a:prstGeom prst="rect">
+            <a:avLst/>
+          </a:prstGeom>
+          <a:noFill/>
+          <a:ln/>
+        </p:spPr>
+        <p:txBody>
+          <a:bodyPr wrap="square" lIns="0" tIns="0" rIns="0" bIns="0" rtlCol="0" anchor="ctr"/>
+          <a:lstStyle/>
+          <a:p>
+            <a:pPr algn="l" indent="0" marL="0">
+              <a:buNone/>
+            </a:pPr>
+            <a:r>
+              <a:rPr lang="en-US" sz="900" spc="200" kern="0" dirty="0">
+                <a:solidFill>
+                  <a:schemeClr val="accent3"/>
+                </a:solidFill>
+                <a:latin typeface="Montserrat" pitchFamily="34" charset="0"/>
+                <a:ea typeface="Montserrat" pitchFamily="34" charset="-122"/>
+                <a:cs typeface="Montserrat" pitchFamily="34" charset="-120"/>
+              </a:rPr>
+              <a:t>eXIOME 2026 · Istanbul</a:t>
+            </a:r>
+            <a:endParaRPr lang="en-US" sz="900" dirty="0"/>
+          </a:p>
+        </p:txBody>
+      </p:sp>
+      <p:sp>
+        <p:nvSpPr>
+          <p:cNvPr id="25" name="Slide Number Placeholder 0"/>
+          <p:cNvSpPr>
+            <a:spLocks noGrp="1"/>
+          </p:cNvSpPr>
+          <p:nvPr>
+            <p:ph type="sldNum" sz="quarter" idx="4294967295"/>
+          </p:nvPr>
+        </p:nvSpPr>
+        <p:spPr>
+          <a:xfrm>
+            <a:off x="11000232" y="6473952"/>
+            <a:ext cx="731520" cy="274320"/>
+          </a:xfrm>
+          <a:prstGeom prst="rect">
+            <a:avLst/>
+          </a:prstGeom>
+          <a:extLst>
+            <a:ext uri="{C572A759-6A51-4108-AA02-DFA0A04FC94B}">
+              <ma14:wrappingTextBoxFlag xmlns:ma14="http://schemas.microsoft.com/office/mac/drawingml/2011/main" val="0"/>
+            </a:ext>
+          </a:extLst>
+        </p:spPr>
+        <p:txBody>
+          <a:bodyPr/>
+          <a:lstStyle>
+            <a:lvl1pPr>
+              <a:defRPr sz="900">
+                <a:solidFill>
+                  <a:schemeClr val="accent3"/>
+                </a:solidFill>
+                <a:latin typeface="Montserrat"/>
+                <a:ea typeface="Montserrat"/>
+                <a:cs typeface="Montserrat"/>
+              </a:defRPr>
+            </a:lvl1pPr>
+          </a:lstStyle>
+          <a:p>
+            <a:pPr algn="r"/>
+            <a:fld id="{F7021451-1387-4CA6-816F-3879F97B5CBC}" type="slidenum">
+              <a:rPr b="0" lang="en-US"/>
+              <a:t>1008</a:t>
+            </a:fld>
+            <a:endParaRPr lang="en-US"/>
           </a:p>
         </p:txBody>
       </p:sp>
@@ -3534,10 +3834,10 @@
       </p:grpSpPr>
       <p:sp>
         <p:nvSpPr>
-          <p:cNvPr id="2" name="Text 1"/>
+          <p:cNvPr id="2" name="Text 2"/>
           <p:cNvSpPr/>
           <p:nvPr>
-            <p:ph idx="102" type="title" hasCustomPrompt="1"/>
+            <p:ph idx="103" type="title" hasCustomPrompt="1"/>
           </p:nvPr>
         </p:nvSpPr>
         <p:spPr>
@@ -3575,10 +3875,10 @@
       </p:sp>
       <p:sp>
         <p:nvSpPr>
-          <p:cNvPr id="3" name="Text 1"/>
+          <p:cNvPr id="3" name="Text 2"/>
           <p:cNvSpPr/>
           <p:nvPr>
-            <p:ph idx="103" type="body" hasCustomPrompt="1"/>
+            <p:ph idx="104" type="body" hasCustomPrompt="1"/>
           </p:nvPr>
         </p:nvSpPr>
         <p:spPr>
@@ -3611,6 +3911,54 @@
               <a:t>Speaker Name — Institution, City, Country</a:t>
             </a:r>
             <a:endParaRPr lang="en-US" sz="2000" dirty="0"/>
+          </a:p>
+        </p:txBody>
+      </p:sp>
+      <p:sp>
+        <p:nvSpPr>
+          <p:cNvPr id="25" name="Slide Number Placeholder 0"/>
+          <p:cNvSpPr>
+            <a:spLocks noGrp="1"/>
+          </p:cNvSpPr>
+          <p:nvPr>
+            <p:ph type="sldNum" sz="quarter" idx="4294967295"/>
+          </p:nvPr>
+        </p:nvSpPr>
+        <p:spPr>
+          <a:xfrm>
+            <a:off x="11000232" y="6473952"/>
+            <a:ext cx="731520" cy="274320"/>
+          </a:xfrm>
+          <a:prstGeom prst="rect">
+            <a:avLst/>
+          </a:prstGeom>
+          <a:extLst>
+            <a:ext uri="{C572A759-6A51-4108-AA02-DFA0A04FC94B}">
+              <ma14:wrappingTextBoxFlag xmlns:ma14="http://schemas.microsoft.com/office/mac/drawingml/2011/main" val="0"/>
+            </a:ext>
+          </a:extLst>
+        </p:spPr>
+        <p:txBody>
+          <a:bodyPr/>
+          <a:lstStyle>
+            <a:lvl1pPr>
+              <a:defRPr sz="900">
+                <a:solidFill>
+                  <a:schemeClr val="accent3"/>
+                </a:solidFill>
+                <a:latin typeface="Montserrat"/>
+                <a:ea typeface="Montserrat"/>
+                <a:cs typeface="Montserrat"/>
+              </a:defRPr>
+            </a:lvl1pPr>
+          </a:lstStyle>
+          <a:p>
+            <a:pPr algn="r"/>
+            <a:fld id="{F7021451-1387-4CA6-816F-3879F97B5CBC}" type="slidenum">
+              <a:rPr b="0" lang="en-US"/>
+              <a:t>2</a:t>
+            </a:fld>
+            <a:endParaRPr lang="en-US"/>
           </a:p>
         </p:txBody>
       </p:sp>
@@ -4729,15 +5077,15 @@
       </p:grpSpPr>
       <p:sp>
         <p:nvSpPr>
-          <p:cNvPr id="2" name="Text 0"/>
+          <p:cNvPr id="2" name="Text 1"/>
           <p:cNvSpPr/>
           <p:nvPr>
-            <p:ph idx="101" type="title" hasCustomPrompt="1"/>
-          </p:nvPr>
-        </p:nvSpPr>
-        <p:spPr>
-          <a:xfrm>
-            <a:off x="1097280" y="3108960"/>
+            <p:ph idx="102" type="title" hasCustomPrompt="1"/>
+          </p:nvPr>
+        </p:nvSpPr>
+        <p:spPr>
+          <a:xfrm>
+            <a:off x="1097280" y="3429000"/>
             <a:ext cx="9994392" cy="914400"/>
           </a:xfrm>
           <a:prstGeom prst="rect">
@@ -4770,15 +5118,15 @@
       </p:sp>
       <p:sp>
         <p:nvSpPr>
-          <p:cNvPr id="3" name="Text 0"/>
+          <p:cNvPr id="3" name="Text 1"/>
           <p:cNvSpPr/>
           <p:nvPr>
-            <p:ph idx="102" type="body" hasCustomPrompt="1"/>
-          </p:nvPr>
-        </p:nvSpPr>
-        <p:spPr>
-          <a:xfrm>
-            <a:off x="1097280" y="4023360"/>
+            <p:ph idx="103" type="body" hasCustomPrompt="1"/>
+          </p:nvPr>
+        </p:nvSpPr>
+        <p:spPr>
+          <a:xfrm>
+            <a:off x="1097280" y="4434840"/>
             <a:ext cx="9994392" cy="548640"/>
           </a:xfrm>
           <a:prstGeom prst="rect">
@@ -4806,6 +5154,54 @@
               <a:t>your.email@institution.org</a:t>
             </a:r>
             <a:endParaRPr lang="en-US" sz="1400" dirty="0"/>
+          </a:p>
+        </p:txBody>
+      </p:sp>
+      <p:sp>
+        <p:nvSpPr>
+          <p:cNvPr id="25" name="Slide Number Placeholder 0"/>
+          <p:cNvSpPr>
+            <a:spLocks noGrp="1"/>
+          </p:cNvSpPr>
+          <p:nvPr>
+            <p:ph type="sldNum" sz="quarter" idx="4294967295"/>
+          </p:nvPr>
+        </p:nvSpPr>
+        <p:spPr>
+          <a:xfrm>
+            <a:off x="11000232" y="6473952"/>
+            <a:ext cx="731520" cy="274320"/>
+          </a:xfrm>
+          <a:prstGeom prst="rect">
+            <a:avLst/>
+          </a:prstGeom>
+          <a:extLst>
+            <a:ext uri="{C572A759-6A51-4108-AA02-DFA0A04FC94B}">
+              <ma14:wrappingTextBoxFlag xmlns:ma14="http://schemas.microsoft.com/office/mac/drawingml/2011/main" val="0"/>
+            </a:ext>
+          </a:extLst>
+        </p:spPr>
+        <p:txBody>
+          <a:bodyPr/>
+          <a:lstStyle>
+            <a:lvl1pPr>
+              <a:defRPr sz="900">
+                <a:solidFill>
+                  <a:schemeClr val="accent3"/>
+                </a:solidFill>
+                <a:latin typeface="Montserrat"/>
+                <a:ea typeface="Montserrat"/>
+                <a:cs typeface="Montserrat"/>
+              </a:defRPr>
+            </a:lvl1pPr>
+          </a:lstStyle>
+          <a:p>
+            <a:pPr algn="r"/>
+            <a:fld id="{F7021451-1387-4CA6-816F-3879F97B5CBC}" type="slidenum">
+              <a:rPr b="0" lang="en-US"/>
+              <a:t>8</a:t>
+            </a:fld>
+            <a:endParaRPr lang="en-US"/>
           </a:p>
         </p:txBody>
       </p:sp>

</xml_diff>

<commit_message>
Add eXIOME acronym meaning to template header and footer
Co-Authored-By: Claude Sonnet 5 <noreply@anthropic.com>
Claude-Session: https://claude.ai/code/session_01FgVjCB936DcAgdSaUcb767
</commit_message>
<xml_diff>
--- a/assets/exiome-2026-speaker-template.pptx
+++ b/assets/exiome-2026-speaker-template.pptx
@@ -114,45 +114,45 @@
   <p:extLst>
     <p:ext uri="{521415D9-36F7-43E2-AB2F-B90AF26B5E84}">
       <p14:sectionLst xmlns:p14="http://schemas.microsoft.com/office/powerpoint/2010/main">
-        <p14:section name="Instructions" id="{f346f4b9-4508-87ec-9df1-7691fcf5cde9}">
+        <p14:section name="Instructions" id="{a6e233e3-5c18-f03b-605c-a6da07d3c377}">
           <p14:sldIdLst/>
         </p14:section>
-        <p14:section name="Default-1" id="{a564d7ff-c566-890a-56b0-b3250325ec77}">
+        <p14:section name="Default-1" id="{55f826ed-b667-12a4-3e22-6b5a4e832f5c}">
           <p14:sldIdLst>
             <p14:sldId id="256"/>
           </p14:sldIdLst>
         </p14:section>
-        <p14:section name="Title" id="{c0cf977d-a13a-28d4-de48-6b266e70867f}">
+        <p14:section name="Title" id="{509cde55-3710-4764-4414-a29eb3baeac8}">
           <p14:sldIdLst>
             <p14:sldId id="257"/>
           </p14:sldIdLst>
         </p14:section>
-        <p14:section name="Section Divider" id="{28ba3ead-4113-eb58-a50a-c810e21f1d69}">
+        <p14:section name="Section Divider" id="{5b1ddb12-9423-7185-4395-9ed5f7491581}">
           <p14:sldIdLst>
             <p14:sldId id="258"/>
           </p14:sldIdLst>
         </p14:section>
-        <p14:section name="Content" id="{1832e4aa-2109-ec4a-f1a4-95c70f0b623b}">
+        <p14:section name="Content" id="{323e4035-456d-783a-1bca-4c47cf8dabd2}">
           <p14:sldIdLst>
             <p14:sldId id="259"/>
           </p14:sldIdLst>
         </p14:section>
-        <p14:section name="Content + Image" id="{914708be-8416-197b-0ad7-ccf8906ea1a3}">
+        <p14:section name="Content + Image" id="{27349f30-102b-4ea3-d6c5-3587ebf786a1}">
           <p14:sldIdLst>
             <p14:sldId id="260"/>
           </p14:sldIdLst>
         </p14:section>
-        <p14:section name="Key Figures" id="{79aa37c1-acbc-56a0-b39d-6724d28a99d4}">
+        <p14:section name="Key Figures" id="{5d5026ea-f524-d36e-0f8f-9ea2d585b8a5}">
           <p14:sldIdLst>
             <p14:sldId id="261"/>
           </p14:sldIdLst>
         </p14:section>
-        <p14:section name="Key Message" id="{a1859d23-e0a4-97be-c99a-57d5ae7fd5ce}">
+        <p14:section name="Key Message" id="{9631c843-8805-23f6-c222-d3fb2e2afb0c}">
           <p14:sldIdLst>
             <p14:sldId id="262"/>
           </p14:sldIdLst>
         </p14:section>
-        <p14:section name="Closing" id="{5ee376b9-8716-4370-c25f-31b2d2ccb70d}">
+        <p14:section name="Closing" id="{a6a4d472-c80e-7d6b-b461-aadec047632a}">
           <p14:sldIdLst>
             <p14:sldId id="263"/>
           </p14:sldIdLst>
@@ -1489,8 +1489,8 @@
         </p:nvSpPr>
         <p:spPr>
           <a:xfrm>
-            <a:off x="0" y="5852160"/>
-            <a:ext cx="12188952" cy="320040"/>
+            <a:off x="0" y="5760720"/>
+            <a:ext cx="12188952" cy="274320"/>
           </a:xfrm>
           <a:prstGeom prst="rect">
             <a:avLst/>
@@ -1536,8 +1536,8 @@
         </p:blipFill>
         <p:spPr>
           <a:xfrm>
-            <a:off x="457200" y="6291072"/>
-            <a:ext cx="1005840" cy="390094"/>
+            <a:off x="457200" y="6144768"/>
+            <a:ext cx="914400" cy="354631"/>
           </a:xfrm>
           <a:prstGeom prst="rect">
             <a:avLst/>
@@ -1552,8 +1552,8 @@
         </p:nvSpPr>
         <p:spPr>
           <a:xfrm>
-            <a:off x="457200" y="6473952"/>
-            <a:ext cx="3657600" cy="274320"/>
+            <a:off x="1508760" y="6181344"/>
+            <a:ext cx="5943600" cy="237744"/>
           </a:xfrm>
           <a:prstGeom prst="rect">
             <a:avLst/>
@@ -1569,9 +1569,9 @@
               <a:buNone/>
             </a:pPr>
             <a:r>
-              <a:rPr lang="en-US" sz="900" spc="200" kern="0" dirty="0">
-                <a:solidFill>
-                  <a:schemeClr val="accent3"/>
+              <a:rPr lang="en-US" sz="900" b="1" spc="150" kern="0" dirty="0">
+                <a:solidFill>
+                  <a:schemeClr val="accent1"/>
                 </a:solidFill>
                 <a:latin typeface="Montserrat" pitchFamily="34" charset="0"/>
                 <a:ea typeface="Montserrat" pitchFamily="34" charset="-122"/>
@@ -1580,6 +1580,45 @@
               <a:t>eXIOME 2026 · Istanbul</a:t>
             </a:r>
             <a:endParaRPr lang="en-US" sz="900" dirty="0"/>
+          </a:p>
+        </p:txBody>
+      </p:sp>
+      <p:sp>
+        <p:nvSpPr>
+          <p:cNvPr id="10" name="Text 4"/>
+          <p:cNvSpPr/>
+          <p:nvPr/>
+        </p:nvSpPr>
+        <p:spPr>
+          <a:xfrm>
+            <a:off x="1508760" y="6419088"/>
+            <a:ext cx="5943600" cy="237744"/>
+          </a:xfrm>
+          <a:prstGeom prst="rect">
+            <a:avLst/>
+          </a:prstGeom>
+          <a:noFill/>
+          <a:ln/>
+        </p:spPr>
+        <p:txBody>
+          <a:bodyPr wrap="square" lIns="0" tIns="0" rIns="0" bIns="0" rtlCol="0" anchor="ctr"/>
+          <a:lstStyle/>
+          <a:p>
+            <a:pPr algn="l" indent="0" marL="0">
+              <a:buNone/>
+            </a:pPr>
+            <a:r>
+              <a:rPr lang="en-US" sz="800" i="1" spc="50" kern="0" dirty="0">
+                <a:solidFill>
+                  <a:schemeClr val="accent3"/>
+                </a:solidFill>
+                <a:latin typeface="Montserrat" pitchFamily="34" charset="0"/>
+                <a:ea typeface="Montserrat" pitchFamily="34" charset="-122"/>
+                <a:cs typeface="Montserrat" pitchFamily="34" charset="-120"/>
+              </a:rPr>
+              <a:t>eXpert International Oncology MEeting</a:t>
+            </a:r>
+            <a:endParaRPr lang="en-US" sz="800" dirty="0"/>
           </a:p>
         </p:txBody>
       </p:sp>
@@ -1595,8 +1634,8 @@
         </p:nvSpPr>
         <p:spPr>
           <a:xfrm>
-            <a:off x="11000232" y="6473952"/>
-            <a:ext cx="731520" cy="274320"/>
+            <a:off x="11000232" y="6181344"/>
+            <a:ext cx="731520" cy="237744"/>
           </a:xfrm>
           <a:prstGeom prst="rect">
             <a:avLst/>
@@ -1755,9 +1794,48 @@
           </a:p>
         </p:txBody>
       </p:sp>
+      <p:sp>
+        <p:nvSpPr>
+          <p:cNvPr id="4" name="Text 1"/>
+          <p:cNvSpPr/>
+          <p:nvPr/>
+        </p:nvSpPr>
+        <p:spPr>
+          <a:xfrm>
+            <a:off x="640080" y="320040"/>
+            <a:ext cx="10908792" cy="274320"/>
+          </a:xfrm>
+          <a:prstGeom prst="rect">
+            <a:avLst/>
+          </a:prstGeom>
+          <a:noFill/>
+          <a:ln/>
+        </p:spPr>
+        <p:txBody>
+          <a:bodyPr wrap="square" lIns="0" tIns="0" rIns="0" bIns="0" rtlCol="0" anchor="ctr"/>
+          <a:lstStyle/>
+          <a:p>
+            <a:pPr algn="r" indent="0" marL="0">
+              <a:buNone/>
+            </a:pPr>
+            <a:r>
+              <a:rPr lang="en-US" sz="900" spc="150" kern="0" dirty="0">
+                <a:solidFill>
+                  <a:schemeClr val="accent3"/>
+                </a:solidFill>
+                <a:latin typeface="Montserrat" pitchFamily="34" charset="0"/>
+                <a:ea typeface="Montserrat" pitchFamily="34" charset="-122"/>
+                <a:cs typeface="Montserrat" pitchFamily="34" charset="-120"/>
+              </a:rPr>
+              <a:t>EXPERT INTERNATIONAL ONCOLOGY MEETING</a:t>
+            </a:r>
+            <a:endParaRPr lang="en-US" sz="900" dirty="0"/>
+          </a:p>
+        </p:txBody>
+      </p:sp>
       <p:pic>
         <p:nvPicPr>
-          <p:cNvPr id="4" name="Image 0" descr="/tmp/claude-0/-home-user/75dcd3eb-4c24-536d-ad40-f01cf5d3cf16/scratchpad/pptx-template/logo.png">    </p:cNvPr>
+          <p:cNvPr id="5" name="Image 0" descr="/tmp/claude-0/-home-user/75dcd3eb-4c24-536d-ad40-f01cf5d3cf16/scratchpad/pptx-template/logo.png">    </p:cNvPr>
           <p:cNvPicPr>
             <a:picLocks noChangeAspect="1"/>
           </p:cNvPicPr>
@@ -1771,8 +1849,8 @@
         </p:blipFill>
         <p:spPr>
           <a:xfrm>
-            <a:off x="457200" y="6291072"/>
-            <a:ext cx="1005840" cy="390094"/>
+            <a:off x="457200" y="6144768"/>
+            <a:ext cx="914400" cy="354631"/>
           </a:xfrm>
           <a:prstGeom prst="rect">
             <a:avLst/>
@@ -1781,14 +1859,14 @@
       </p:pic>
       <p:sp>
         <p:nvSpPr>
-          <p:cNvPr id="5" name="Text 1"/>
+          <p:cNvPr id="6" name="Text 2"/>
           <p:cNvSpPr/>
           <p:nvPr/>
         </p:nvSpPr>
         <p:spPr>
           <a:xfrm>
-            <a:off x="457200" y="6473952"/>
-            <a:ext cx="3657600" cy="274320"/>
+            <a:off x="1508760" y="6181344"/>
+            <a:ext cx="5943600" cy="237744"/>
           </a:xfrm>
           <a:prstGeom prst="rect">
             <a:avLst/>
@@ -1804,9 +1882,9 @@
               <a:buNone/>
             </a:pPr>
             <a:r>
-              <a:rPr lang="en-US" sz="900" spc="200" kern="0" dirty="0">
-                <a:solidFill>
-                  <a:schemeClr val="accent3"/>
+              <a:rPr lang="en-US" sz="900" b="1" spc="150" kern="0" dirty="0">
+                <a:solidFill>
+                  <a:schemeClr val="accent1"/>
                 </a:solidFill>
                 <a:latin typeface="Montserrat" pitchFamily="34" charset="0"/>
                 <a:ea typeface="Montserrat" pitchFamily="34" charset="-122"/>
@@ -1815,6 +1893,45 @@
               <a:t>eXIOME 2026 · Istanbul</a:t>
             </a:r>
             <a:endParaRPr lang="en-US" sz="900" dirty="0"/>
+          </a:p>
+        </p:txBody>
+      </p:sp>
+      <p:sp>
+        <p:nvSpPr>
+          <p:cNvPr id="7" name="Text 3"/>
+          <p:cNvSpPr/>
+          <p:nvPr/>
+        </p:nvSpPr>
+        <p:spPr>
+          <a:xfrm>
+            <a:off x="1508760" y="6419088"/>
+            <a:ext cx="5943600" cy="237744"/>
+          </a:xfrm>
+          <a:prstGeom prst="rect">
+            <a:avLst/>
+          </a:prstGeom>
+          <a:noFill/>
+          <a:ln/>
+        </p:spPr>
+        <p:txBody>
+          <a:bodyPr wrap="square" lIns="0" tIns="0" rIns="0" bIns="0" rtlCol="0" anchor="ctr"/>
+          <a:lstStyle/>
+          <a:p>
+            <a:pPr algn="l" indent="0" marL="0">
+              <a:buNone/>
+            </a:pPr>
+            <a:r>
+              <a:rPr lang="en-US" sz="800" i="1" spc="50" kern="0" dirty="0">
+                <a:solidFill>
+                  <a:schemeClr val="accent3"/>
+                </a:solidFill>
+                <a:latin typeface="Montserrat" pitchFamily="34" charset="0"/>
+                <a:ea typeface="Montserrat" pitchFamily="34" charset="-122"/>
+                <a:cs typeface="Montserrat" pitchFamily="34" charset="-120"/>
+              </a:rPr>
+              <a:t>eXpert International Oncology MEeting</a:t>
+            </a:r>
+            <a:endParaRPr lang="en-US" sz="800" dirty="0"/>
           </a:p>
         </p:txBody>
       </p:sp>
@@ -1830,8 +1947,8 @@
         </p:nvSpPr>
         <p:spPr>
           <a:xfrm>
-            <a:off x="11000232" y="6473952"/>
-            <a:ext cx="731520" cy="274320"/>
+            <a:off x="11000232" y="6181344"/>
+            <a:ext cx="731520" cy="237744"/>
           </a:xfrm>
           <a:prstGeom prst="rect">
             <a:avLst/>
@@ -1908,7 +2025,7 @@
         </p:nvSpPr>
         <p:spPr>
           <a:xfrm>
-            <a:off x="640080" y="457200"/>
+            <a:off x="640080" y="777240"/>
             <a:ext cx="10908792" cy="822960"/>
           </a:xfrm>
           <a:prstGeom prst="rect">
@@ -1961,8 +2078,8 @@
         </p:nvSpPr>
         <p:spPr>
           <a:xfrm>
-            <a:off x="640080" y="1463040"/>
-            <a:ext cx="10908792" cy="4572000"/>
+            <a:off x="640080" y="1783080"/>
+            <a:ext cx="10908792" cy="4069080"/>
           </a:xfrm>
           <a:prstGeom prst="rect">
             <a:avLst/>
@@ -2010,9 +2127,48 @@
           </a:p>
         </p:txBody>
       </p:sp>
+      <p:sp>
+        <p:nvSpPr>
+          <p:cNvPr id="4" name="Text 0"/>
+          <p:cNvSpPr/>
+          <p:nvPr/>
+        </p:nvSpPr>
+        <p:spPr>
+          <a:xfrm>
+            <a:off x="640080" y="320040"/>
+            <a:ext cx="10908792" cy="274320"/>
+          </a:xfrm>
+          <a:prstGeom prst="rect">
+            <a:avLst/>
+          </a:prstGeom>
+          <a:noFill/>
+          <a:ln/>
+        </p:spPr>
+        <p:txBody>
+          <a:bodyPr wrap="square" lIns="0" tIns="0" rIns="0" bIns="0" rtlCol="0" anchor="ctr"/>
+          <a:lstStyle/>
+          <a:p>
+            <a:pPr algn="r" indent="0" marL="0">
+              <a:buNone/>
+            </a:pPr>
+            <a:r>
+              <a:rPr lang="en-US" sz="900" spc="150" kern="0" dirty="0">
+                <a:solidFill>
+                  <a:schemeClr val="accent3"/>
+                </a:solidFill>
+                <a:latin typeface="Montserrat" pitchFamily="34" charset="0"/>
+                <a:ea typeface="Montserrat" pitchFamily="34" charset="-122"/>
+                <a:cs typeface="Montserrat" pitchFamily="34" charset="-120"/>
+              </a:rPr>
+              <a:t>EXPERT INTERNATIONAL ONCOLOGY MEETING</a:t>
+            </a:r>
+            <a:endParaRPr lang="en-US" sz="900" dirty="0"/>
+          </a:p>
+        </p:txBody>
+      </p:sp>
       <p:pic>
         <p:nvPicPr>
-          <p:cNvPr id="4" name="Image 0" descr="/tmp/claude-0/-home-user/75dcd3eb-4c24-536d-ad40-f01cf5d3cf16/scratchpad/pptx-template/logo.png">    </p:cNvPr>
+          <p:cNvPr id="5" name="Image 0" descr="/tmp/claude-0/-home-user/75dcd3eb-4c24-536d-ad40-f01cf5d3cf16/scratchpad/pptx-template/logo.png">    </p:cNvPr>
           <p:cNvPicPr>
             <a:picLocks noChangeAspect="1"/>
           </p:cNvPicPr>
@@ -2026,8 +2182,8 @@
         </p:blipFill>
         <p:spPr>
           <a:xfrm>
-            <a:off x="457200" y="6291072"/>
-            <a:ext cx="1005840" cy="390094"/>
+            <a:off x="457200" y="6144768"/>
+            <a:ext cx="914400" cy="354631"/>
           </a:xfrm>
           <a:prstGeom prst="rect">
             <a:avLst/>
@@ -2036,14 +2192,14 @@
       </p:pic>
       <p:sp>
         <p:nvSpPr>
-          <p:cNvPr id="5" name="Text 0"/>
+          <p:cNvPr id="6" name="Text 1"/>
           <p:cNvSpPr/>
           <p:nvPr/>
         </p:nvSpPr>
         <p:spPr>
           <a:xfrm>
-            <a:off x="457200" y="6473952"/>
-            <a:ext cx="3657600" cy="274320"/>
+            <a:off x="1508760" y="6181344"/>
+            <a:ext cx="5943600" cy="237744"/>
           </a:xfrm>
           <a:prstGeom prst="rect">
             <a:avLst/>
@@ -2059,9 +2215,9 @@
               <a:buNone/>
             </a:pPr>
             <a:r>
-              <a:rPr lang="en-US" sz="900" spc="200" kern="0" dirty="0">
-                <a:solidFill>
-                  <a:schemeClr val="accent3"/>
+              <a:rPr lang="en-US" sz="900" b="1" spc="150" kern="0" dirty="0">
+                <a:solidFill>
+                  <a:schemeClr val="accent1"/>
                 </a:solidFill>
                 <a:latin typeface="Montserrat" pitchFamily="34" charset="0"/>
                 <a:ea typeface="Montserrat" pitchFamily="34" charset="-122"/>
@@ -2070,6 +2226,45 @@
               <a:t>eXIOME 2026 · Istanbul</a:t>
             </a:r>
             <a:endParaRPr lang="en-US" sz="900" dirty="0"/>
+          </a:p>
+        </p:txBody>
+      </p:sp>
+      <p:sp>
+        <p:nvSpPr>
+          <p:cNvPr id="7" name="Text 2"/>
+          <p:cNvSpPr/>
+          <p:nvPr/>
+        </p:nvSpPr>
+        <p:spPr>
+          <a:xfrm>
+            <a:off x="1508760" y="6419088"/>
+            <a:ext cx="5943600" cy="237744"/>
+          </a:xfrm>
+          <a:prstGeom prst="rect">
+            <a:avLst/>
+          </a:prstGeom>
+          <a:noFill/>
+          <a:ln/>
+        </p:spPr>
+        <p:txBody>
+          <a:bodyPr wrap="square" lIns="0" tIns="0" rIns="0" bIns="0" rtlCol="0" anchor="ctr"/>
+          <a:lstStyle/>
+          <a:p>
+            <a:pPr algn="l" indent="0" marL="0">
+              <a:buNone/>
+            </a:pPr>
+            <a:r>
+              <a:rPr lang="en-US" sz="800" i="1" spc="50" kern="0" dirty="0">
+                <a:solidFill>
+                  <a:schemeClr val="accent3"/>
+                </a:solidFill>
+                <a:latin typeface="Montserrat" pitchFamily="34" charset="0"/>
+                <a:ea typeface="Montserrat" pitchFamily="34" charset="-122"/>
+                <a:cs typeface="Montserrat" pitchFamily="34" charset="-120"/>
+              </a:rPr>
+              <a:t>eXpert International Oncology MEeting</a:t>
+            </a:r>
+            <a:endParaRPr lang="en-US" sz="800" dirty="0"/>
           </a:p>
         </p:txBody>
       </p:sp>
@@ -2085,8 +2280,8 @@
         </p:nvSpPr>
         <p:spPr>
           <a:xfrm>
-            <a:off x="11000232" y="6473952"/>
-            <a:ext cx="731520" cy="274320"/>
+            <a:off x="11000232" y="6181344"/>
+            <a:ext cx="731520" cy="237744"/>
           </a:xfrm>
           <a:prstGeom prst="rect">
             <a:avLst/>
@@ -2163,7 +2358,7 @@
         </p:nvSpPr>
         <p:spPr>
           <a:xfrm>
-            <a:off x="640080" y="457200"/>
+            <a:off x="640080" y="777240"/>
             <a:ext cx="10908792" cy="822960"/>
           </a:xfrm>
           <a:prstGeom prst="rect">
@@ -2216,8 +2411,8 @@
         </p:nvSpPr>
         <p:spPr>
           <a:xfrm>
-            <a:off x="640080" y="1463040"/>
-            <a:ext cx="5212080" cy="4572000"/>
+            <a:off x="640080" y="1783080"/>
+            <a:ext cx="5212080" cy="4069080"/>
           </a:xfrm>
           <a:prstGeom prst="rect">
             <a:avLst/>
@@ -2273,8 +2468,8 @@
         </p:nvSpPr>
         <p:spPr>
           <a:xfrm>
-            <a:off x="6217920" y="1463040"/>
-            <a:ext cx="5330952" cy="4572000"/>
+            <a:off x="6217920" y="1783080"/>
+            <a:ext cx="5330952" cy="4069080"/>
           </a:xfrm>
           <a:prstGeom prst="rect">
             <a:avLst/>
@@ -2300,8 +2495,8 @@
         </p:nvSpPr>
         <p:spPr>
           <a:xfrm>
-            <a:off x="6217920" y="1463040"/>
-            <a:ext cx="5330952" cy="4572000"/>
+            <a:off x="6217920" y="1783080"/>
+            <a:ext cx="5330952" cy="4069080"/>
           </a:xfrm>
           <a:prstGeom prst="rect">
             <a:avLst/>
@@ -2325,9 +2520,48 @@
           </a:p>
         </p:txBody>
       </p:sp>
+      <p:sp>
+        <p:nvSpPr>
+          <p:cNvPr id="6" name="Text 1"/>
+          <p:cNvSpPr/>
+          <p:nvPr/>
+        </p:nvSpPr>
+        <p:spPr>
+          <a:xfrm>
+            <a:off x="640080" y="320040"/>
+            <a:ext cx="10908792" cy="274320"/>
+          </a:xfrm>
+          <a:prstGeom prst="rect">
+            <a:avLst/>
+          </a:prstGeom>
+          <a:noFill/>
+          <a:ln/>
+        </p:spPr>
+        <p:txBody>
+          <a:bodyPr wrap="square" lIns="0" tIns="0" rIns="0" bIns="0" rtlCol="0" anchor="ctr"/>
+          <a:lstStyle/>
+          <a:p>
+            <a:pPr algn="r" indent="0" marL="0">
+              <a:buNone/>
+            </a:pPr>
+            <a:r>
+              <a:rPr lang="en-US" sz="900" spc="150" kern="0" dirty="0">
+                <a:solidFill>
+                  <a:schemeClr val="accent3"/>
+                </a:solidFill>
+                <a:latin typeface="Montserrat" pitchFamily="34" charset="0"/>
+                <a:ea typeface="Montserrat" pitchFamily="34" charset="-122"/>
+                <a:cs typeface="Montserrat" pitchFamily="34" charset="-120"/>
+              </a:rPr>
+              <a:t>EXPERT INTERNATIONAL ONCOLOGY MEETING</a:t>
+            </a:r>
+            <a:endParaRPr lang="en-US" sz="900" dirty="0"/>
+          </a:p>
+        </p:txBody>
+      </p:sp>
       <p:pic>
         <p:nvPicPr>
-          <p:cNvPr id="6" name="Image 0" descr="/tmp/claude-0/-home-user/75dcd3eb-4c24-536d-ad40-f01cf5d3cf16/scratchpad/pptx-template/logo.png">    </p:cNvPr>
+          <p:cNvPr id="7" name="Image 0" descr="/tmp/claude-0/-home-user/75dcd3eb-4c24-536d-ad40-f01cf5d3cf16/scratchpad/pptx-template/logo.png">    </p:cNvPr>
           <p:cNvPicPr>
             <a:picLocks noChangeAspect="1"/>
           </p:cNvPicPr>
@@ -2341,8 +2575,8 @@
         </p:blipFill>
         <p:spPr>
           <a:xfrm>
-            <a:off x="457200" y="6291072"/>
-            <a:ext cx="1005840" cy="390094"/>
+            <a:off x="457200" y="6144768"/>
+            <a:ext cx="914400" cy="354631"/>
           </a:xfrm>
           <a:prstGeom prst="rect">
             <a:avLst/>
@@ -2351,14 +2585,14 @@
       </p:pic>
       <p:sp>
         <p:nvSpPr>
-          <p:cNvPr id="7" name="Text 1"/>
+          <p:cNvPr id="8" name="Text 2"/>
           <p:cNvSpPr/>
           <p:nvPr/>
         </p:nvSpPr>
         <p:spPr>
           <a:xfrm>
-            <a:off x="457200" y="6473952"/>
-            <a:ext cx="3657600" cy="274320"/>
+            <a:off x="1508760" y="6181344"/>
+            <a:ext cx="5943600" cy="237744"/>
           </a:xfrm>
           <a:prstGeom prst="rect">
             <a:avLst/>
@@ -2374,9 +2608,9 @@
               <a:buNone/>
             </a:pPr>
             <a:r>
-              <a:rPr lang="en-US" sz="900" spc="200" kern="0" dirty="0">
-                <a:solidFill>
-                  <a:schemeClr val="accent3"/>
+              <a:rPr lang="en-US" sz="900" b="1" spc="150" kern="0" dirty="0">
+                <a:solidFill>
+                  <a:schemeClr val="accent1"/>
                 </a:solidFill>
                 <a:latin typeface="Montserrat" pitchFamily="34" charset="0"/>
                 <a:ea typeface="Montserrat" pitchFamily="34" charset="-122"/>
@@ -2385,6 +2619,45 @@
               <a:t>eXIOME 2026 · Istanbul</a:t>
             </a:r>
             <a:endParaRPr lang="en-US" sz="900" dirty="0"/>
+          </a:p>
+        </p:txBody>
+      </p:sp>
+      <p:sp>
+        <p:nvSpPr>
+          <p:cNvPr id="9" name="Text 3"/>
+          <p:cNvSpPr/>
+          <p:nvPr/>
+        </p:nvSpPr>
+        <p:spPr>
+          <a:xfrm>
+            <a:off x="1508760" y="6419088"/>
+            <a:ext cx="5943600" cy="237744"/>
+          </a:xfrm>
+          <a:prstGeom prst="rect">
+            <a:avLst/>
+          </a:prstGeom>
+          <a:noFill/>
+          <a:ln/>
+        </p:spPr>
+        <p:txBody>
+          <a:bodyPr wrap="square" lIns="0" tIns="0" rIns="0" bIns="0" rtlCol="0" anchor="ctr"/>
+          <a:lstStyle/>
+          <a:p>
+            <a:pPr algn="l" indent="0" marL="0">
+              <a:buNone/>
+            </a:pPr>
+            <a:r>
+              <a:rPr lang="en-US" sz="800" i="1" spc="50" kern="0" dirty="0">
+                <a:solidFill>
+                  <a:schemeClr val="accent3"/>
+                </a:solidFill>
+                <a:latin typeface="Montserrat" pitchFamily="34" charset="0"/>
+                <a:ea typeface="Montserrat" pitchFamily="34" charset="-122"/>
+                <a:cs typeface="Montserrat" pitchFamily="34" charset="-120"/>
+              </a:rPr>
+              <a:t>eXpert International Oncology MEeting</a:t>
+            </a:r>
+            <a:endParaRPr lang="en-US" sz="800" dirty="0"/>
           </a:p>
         </p:txBody>
       </p:sp>
@@ -2400,8 +2673,8 @@
         </p:nvSpPr>
         <p:spPr>
           <a:xfrm>
-            <a:off x="11000232" y="6473952"/>
-            <a:ext cx="731520" cy="274320"/>
+            <a:off x="11000232" y="6181344"/>
+            <a:ext cx="731520" cy="237744"/>
           </a:xfrm>
           <a:prstGeom prst="rect">
             <a:avLst/>
@@ -2478,7 +2751,7 @@
         </p:nvSpPr>
         <p:spPr>
           <a:xfrm>
-            <a:off x="640080" y="457200"/>
+            <a:off x="640080" y="777240"/>
             <a:ext cx="10908792" cy="822960"/>
           </a:xfrm>
           <a:prstGeom prst="rect">
@@ -2521,9 +2794,48 @@
           </a:p>
         </p:txBody>
       </p:sp>
+      <p:sp>
+        <p:nvSpPr>
+          <p:cNvPr id="3" name="Text 0"/>
+          <p:cNvSpPr/>
+          <p:nvPr/>
+        </p:nvSpPr>
+        <p:spPr>
+          <a:xfrm>
+            <a:off x="640080" y="320040"/>
+            <a:ext cx="10908792" cy="274320"/>
+          </a:xfrm>
+          <a:prstGeom prst="rect">
+            <a:avLst/>
+          </a:prstGeom>
+          <a:noFill/>
+          <a:ln/>
+        </p:spPr>
+        <p:txBody>
+          <a:bodyPr wrap="square" lIns="0" tIns="0" rIns="0" bIns="0" rtlCol="0" anchor="ctr"/>
+          <a:lstStyle/>
+          <a:p>
+            <a:pPr algn="r" indent="0" marL="0">
+              <a:buNone/>
+            </a:pPr>
+            <a:r>
+              <a:rPr lang="en-US" sz="900" spc="150" kern="0" dirty="0">
+                <a:solidFill>
+                  <a:schemeClr val="accent3"/>
+                </a:solidFill>
+                <a:latin typeface="Montserrat" pitchFamily="34" charset="0"/>
+                <a:ea typeface="Montserrat" pitchFamily="34" charset="-122"/>
+                <a:cs typeface="Montserrat" pitchFamily="34" charset="-120"/>
+              </a:rPr>
+              <a:t>EXPERT INTERNATIONAL ONCOLOGY MEETING</a:t>
+            </a:r>
+            <a:endParaRPr lang="en-US" sz="900" dirty="0"/>
+          </a:p>
+        </p:txBody>
+      </p:sp>
       <p:pic>
         <p:nvPicPr>
-          <p:cNvPr id="3" name="Image 0" descr="/tmp/claude-0/-home-user/75dcd3eb-4c24-536d-ad40-f01cf5d3cf16/scratchpad/pptx-template/logo.png">    </p:cNvPr>
+          <p:cNvPr id="4" name="Image 0" descr="/tmp/claude-0/-home-user/75dcd3eb-4c24-536d-ad40-f01cf5d3cf16/scratchpad/pptx-template/logo.png">    </p:cNvPr>
           <p:cNvPicPr>
             <a:picLocks noChangeAspect="1"/>
           </p:cNvPicPr>
@@ -2537,8 +2849,8 @@
         </p:blipFill>
         <p:spPr>
           <a:xfrm>
-            <a:off x="457200" y="6291072"/>
-            <a:ext cx="1005840" cy="390094"/>
+            <a:off x="457200" y="6144768"/>
+            <a:ext cx="914400" cy="354631"/>
           </a:xfrm>
           <a:prstGeom prst="rect">
             <a:avLst/>
@@ -2547,14 +2859,14 @@
       </p:pic>
       <p:sp>
         <p:nvSpPr>
-          <p:cNvPr id="4" name="Text 0"/>
+          <p:cNvPr id="5" name="Text 1"/>
           <p:cNvSpPr/>
           <p:nvPr/>
         </p:nvSpPr>
         <p:spPr>
           <a:xfrm>
-            <a:off x="457200" y="6473952"/>
-            <a:ext cx="3657600" cy="274320"/>
+            <a:off x="1508760" y="6181344"/>
+            <a:ext cx="5943600" cy="237744"/>
           </a:xfrm>
           <a:prstGeom prst="rect">
             <a:avLst/>
@@ -2570,9 +2882,9 @@
               <a:buNone/>
             </a:pPr>
             <a:r>
-              <a:rPr lang="en-US" sz="900" spc="200" kern="0" dirty="0">
-                <a:solidFill>
-                  <a:schemeClr val="accent3"/>
+              <a:rPr lang="en-US" sz="900" b="1" spc="150" kern="0" dirty="0">
+                <a:solidFill>
+                  <a:schemeClr val="accent1"/>
                 </a:solidFill>
                 <a:latin typeface="Montserrat" pitchFamily="34" charset="0"/>
                 <a:ea typeface="Montserrat" pitchFamily="34" charset="-122"/>
@@ -2581,6 +2893,45 @@
               <a:t>eXIOME 2026 · Istanbul</a:t>
             </a:r>
             <a:endParaRPr lang="en-US" sz="900" dirty="0"/>
+          </a:p>
+        </p:txBody>
+      </p:sp>
+      <p:sp>
+        <p:nvSpPr>
+          <p:cNvPr id="6" name="Text 2"/>
+          <p:cNvSpPr/>
+          <p:nvPr/>
+        </p:nvSpPr>
+        <p:spPr>
+          <a:xfrm>
+            <a:off x="1508760" y="6419088"/>
+            <a:ext cx="5943600" cy="237744"/>
+          </a:xfrm>
+          <a:prstGeom prst="rect">
+            <a:avLst/>
+          </a:prstGeom>
+          <a:noFill/>
+          <a:ln/>
+        </p:spPr>
+        <p:txBody>
+          <a:bodyPr wrap="square" lIns="0" tIns="0" rIns="0" bIns="0" rtlCol="0" anchor="ctr"/>
+          <a:lstStyle/>
+          <a:p>
+            <a:pPr algn="l" indent="0" marL="0">
+              <a:buNone/>
+            </a:pPr>
+            <a:r>
+              <a:rPr lang="en-US" sz="800" i="1" spc="50" kern="0" dirty="0">
+                <a:solidFill>
+                  <a:schemeClr val="accent3"/>
+                </a:solidFill>
+                <a:latin typeface="Montserrat" pitchFamily="34" charset="0"/>
+                <a:ea typeface="Montserrat" pitchFamily="34" charset="-122"/>
+                <a:cs typeface="Montserrat" pitchFamily="34" charset="-120"/>
+              </a:rPr>
+              <a:t>eXpert International Oncology MEeting</a:t>
+            </a:r>
+            <a:endParaRPr lang="en-US" sz="800" dirty="0"/>
           </a:p>
         </p:txBody>
       </p:sp>
@@ -2596,8 +2947,8 @@
         </p:nvSpPr>
         <p:spPr>
           <a:xfrm>
-            <a:off x="11000232" y="6473952"/>
-            <a:ext cx="731520" cy="274320"/>
+            <a:off x="11000232" y="6181344"/>
+            <a:ext cx="731520" cy="237744"/>
           </a:xfrm>
           <a:prstGeom prst="rect">
             <a:avLst/>
@@ -2809,9 +3160,48 @@
           </a:p>
         </p:txBody>
       </p:sp>
+      <p:sp>
+        <p:nvSpPr>
+          <p:cNvPr id="5" name="Text 1"/>
+          <p:cNvSpPr/>
+          <p:nvPr/>
+        </p:nvSpPr>
+        <p:spPr>
+          <a:xfrm>
+            <a:off x="640080" y="320040"/>
+            <a:ext cx="10908792" cy="274320"/>
+          </a:xfrm>
+          <a:prstGeom prst="rect">
+            <a:avLst/>
+          </a:prstGeom>
+          <a:noFill/>
+          <a:ln/>
+        </p:spPr>
+        <p:txBody>
+          <a:bodyPr wrap="square" lIns="0" tIns="0" rIns="0" bIns="0" rtlCol="0" anchor="ctr"/>
+          <a:lstStyle/>
+          <a:p>
+            <a:pPr algn="r" indent="0" marL="0">
+              <a:buNone/>
+            </a:pPr>
+            <a:r>
+              <a:rPr lang="en-US" sz="900" spc="150" kern="0" dirty="0">
+                <a:solidFill>
+                  <a:schemeClr val="accent3"/>
+                </a:solidFill>
+                <a:latin typeface="Montserrat" pitchFamily="34" charset="0"/>
+                <a:ea typeface="Montserrat" pitchFamily="34" charset="-122"/>
+                <a:cs typeface="Montserrat" pitchFamily="34" charset="-120"/>
+              </a:rPr>
+              <a:t>EXPERT INTERNATIONAL ONCOLOGY MEETING</a:t>
+            </a:r>
+            <a:endParaRPr lang="en-US" sz="900" dirty="0"/>
+          </a:p>
+        </p:txBody>
+      </p:sp>
       <p:pic>
         <p:nvPicPr>
-          <p:cNvPr id="5" name="Image 0" descr="/tmp/claude-0/-home-user/75dcd3eb-4c24-536d-ad40-f01cf5d3cf16/scratchpad/pptx-template/logo.png">    </p:cNvPr>
+          <p:cNvPr id="6" name="Image 0" descr="/tmp/claude-0/-home-user/75dcd3eb-4c24-536d-ad40-f01cf5d3cf16/scratchpad/pptx-template/logo.png">    </p:cNvPr>
           <p:cNvPicPr>
             <a:picLocks noChangeAspect="1"/>
           </p:cNvPicPr>
@@ -2825,8 +3215,8 @@
         </p:blipFill>
         <p:spPr>
           <a:xfrm>
-            <a:off x="457200" y="6291072"/>
-            <a:ext cx="1005840" cy="390094"/>
+            <a:off x="457200" y="6144768"/>
+            <a:ext cx="914400" cy="354631"/>
           </a:xfrm>
           <a:prstGeom prst="rect">
             <a:avLst/>
@@ -2835,14 +3225,14 @@
       </p:pic>
       <p:sp>
         <p:nvSpPr>
-          <p:cNvPr id="6" name="Text 1"/>
+          <p:cNvPr id="7" name="Text 2"/>
           <p:cNvSpPr/>
           <p:nvPr/>
         </p:nvSpPr>
         <p:spPr>
           <a:xfrm>
-            <a:off x="457200" y="6473952"/>
-            <a:ext cx="3657600" cy="274320"/>
+            <a:off x="1508760" y="6181344"/>
+            <a:ext cx="5943600" cy="237744"/>
           </a:xfrm>
           <a:prstGeom prst="rect">
             <a:avLst/>
@@ -2858,9 +3248,9 @@
               <a:buNone/>
             </a:pPr>
             <a:r>
-              <a:rPr lang="en-US" sz="900" spc="200" kern="0" dirty="0">
-                <a:solidFill>
-                  <a:schemeClr val="accent3"/>
+              <a:rPr lang="en-US" sz="900" b="1" spc="150" kern="0" dirty="0">
+                <a:solidFill>
+                  <a:schemeClr val="accent1"/>
                 </a:solidFill>
                 <a:latin typeface="Montserrat" pitchFamily="34" charset="0"/>
                 <a:ea typeface="Montserrat" pitchFamily="34" charset="-122"/>
@@ -2869,6 +3259,45 @@
               <a:t>eXIOME 2026 · Istanbul</a:t>
             </a:r>
             <a:endParaRPr lang="en-US" sz="900" dirty="0"/>
+          </a:p>
+        </p:txBody>
+      </p:sp>
+      <p:sp>
+        <p:nvSpPr>
+          <p:cNvPr id="8" name="Text 3"/>
+          <p:cNvSpPr/>
+          <p:nvPr/>
+        </p:nvSpPr>
+        <p:spPr>
+          <a:xfrm>
+            <a:off x="1508760" y="6419088"/>
+            <a:ext cx="5943600" cy="237744"/>
+          </a:xfrm>
+          <a:prstGeom prst="rect">
+            <a:avLst/>
+          </a:prstGeom>
+          <a:noFill/>
+          <a:ln/>
+        </p:spPr>
+        <p:txBody>
+          <a:bodyPr wrap="square" lIns="0" tIns="0" rIns="0" bIns="0" rtlCol="0" anchor="ctr"/>
+          <a:lstStyle/>
+          <a:p>
+            <a:pPr algn="l" indent="0" marL="0">
+              <a:buNone/>
+            </a:pPr>
+            <a:r>
+              <a:rPr lang="en-US" sz="800" i="1" spc="50" kern="0" dirty="0">
+                <a:solidFill>
+                  <a:schemeClr val="accent3"/>
+                </a:solidFill>
+                <a:latin typeface="Montserrat" pitchFamily="34" charset="0"/>
+                <a:ea typeface="Montserrat" pitchFamily="34" charset="-122"/>
+                <a:cs typeface="Montserrat" pitchFamily="34" charset="-120"/>
+              </a:rPr>
+              <a:t>eXpert International Oncology MEeting</a:t>
+            </a:r>
+            <a:endParaRPr lang="en-US" sz="800" dirty="0"/>
           </a:p>
         </p:txBody>
       </p:sp>
@@ -2884,8 +3313,8 @@
         </p:nvSpPr>
         <p:spPr>
           <a:xfrm>
-            <a:off x="11000232" y="6473952"/>
-            <a:ext cx="731520" cy="274320"/>
+            <a:off x="11000232" y="6181344"/>
+            <a:ext cx="731520" cy="237744"/>
           </a:xfrm>
           <a:prstGeom prst="rect">
             <a:avLst/>
@@ -3137,8 +3566,8 @@
         </p:blipFill>
         <p:spPr>
           <a:xfrm>
-            <a:off x="457200" y="6291072"/>
-            <a:ext cx="1005840" cy="390094"/>
+            <a:off x="457200" y="6144768"/>
+            <a:ext cx="914400" cy="354631"/>
           </a:xfrm>
           <a:prstGeom prst="rect">
             <a:avLst/>
@@ -3153,8 +3582,8 @@
         </p:nvSpPr>
         <p:spPr>
           <a:xfrm>
-            <a:off x="457200" y="6473952"/>
-            <a:ext cx="3657600" cy="274320"/>
+            <a:off x="1508760" y="6181344"/>
+            <a:ext cx="5943600" cy="237744"/>
           </a:xfrm>
           <a:prstGeom prst="rect">
             <a:avLst/>
@@ -3170,9 +3599,9 @@
               <a:buNone/>
             </a:pPr>
             <a:r>
-              <a:rPr lang="en-US" sz="900" spc="200" kern="0" dirty="0">
-                <a:solidFill>
-                  <a:schemeClr val="accent3"/>
+              <a:rPr lang="en-US" sz="900" b="1" spc="150" kern="0" dirty="0">
+                <a:solidFill>
+                  <a:schemeClr val="accent1"/>
                 </a:solidFill>
                 <a:latin typeface="Montserrat" pitchFamily="34" charset="0"/>
                 <a:ea typeface="Montserrat" pitchFamily="34" charset="-122"/>
@@ -3181,6 +3610,45 @@
               <a:t>eXIOME 2026 · Istanbul</a:t>
             </a:r>
             <a:endParaRPr lang="en-US" sz="900" dirty="0"/>
+          </a:p>
+        </p:txBody>
+      </p:sp>
+      <p:sp>
+        <p:nvSpPr>
+          <p:cNvPr id="8" name="Text 2"/>
+          <p:cNvSpPr/>
+          <p:nvPr/>
+        </p:nvSpPr>
+        <p:spPr>
+          <a:xfrm>
+            <a:off x="1508760" y="6419088"/>
+            <a:ext cx="5943600" cy="237744"/>
+          </a:xfrm>
+          <a:prstGeom prst="rect">
+            <a:avLst/>
+          </a:prstGeom>
+          <a:noFill/>
+          <a:ln/>
+        </p:spPr>
+        <p:txBody>
+          <a:bodyPr wrap="square" lIns="0" tIns="0" rIns="0" bIns="0" rtlCol="0" anchor="ctr"/>
+          <a:lstStyle/>
+          <a:p>
+            <a:pPr algn="l" indent="0" marL="0">
+              <a:buNone/>
+            </a:pPr>
+            <a:r>
+              <a:rPr lang="en-US" sz="800" i="1" spc="50" kern="0" dirty="0">
+                <a:solidFill>
+                  <a:schemeClr val="accent3"/>
+                </a:solidFill>
+                <a:latin typeface="Montserrat" pitchFamily="34" charset="0"/>
+                <a:ea typeface="Montserrat" pitchFamily="34" charset="-122"/>
+                <a:cs typeface="Montserrat" pitchFamily="34" charset="-120"/>
+              </a:rPr>
+              <a:t>eXpert International Oncology MEeting</a:t>
+            </a:r>
+            <a:endParaRPr lang="en-US" sz="800" dirty="0"/>
           </a:p>
         </p:txBody>
       </p:sp>
@@ -3196,8 +3664,8 @@
         </p:nvSpPr>
         <p:spPr>
           <a:xfrm>
-            <a:off x="11000232" y="6473952"/>
-            <a:ext cx="731520" cy="274320"/>
+            <a:off x="11000232" y="6181344"/>
+            <a:ext cx="731520" cy="237744"/>
           </a:xfrm>
           <a:prstGeom prst="rect">
             <a:avLst/>
@@ -3269,8 +3737,8 @@
         </p:nvSpPr>
         <p:spPr>
           <a:xfrm>
-            <a:off x="11000232" y="6473952"/>
-            <a:ext cx="731520" cy="274320"/>
+            <a:off x="11000232" y="6181344"/>
+            <a:ext cx="731520" cy="237744"/>
           </a:xfrm>
           <a:prstGeom prst="rect">
             <a:avLst/>
@@ -3599,7 +4067,7 @@
         </p:nvSpPr>
         <p:spPr>
           <a:xfrm>
-            <a:off x="640080" y="457200"/>
+            <a:off x="640080" y="777240"/>
             <a:ext cx="10908792" cy="822960"/>
           </a:xfrm>
           <a:prstGeom prst="rect">
@@ -3640,8 +4108,8 @@
         </p:nvSpPr>
         <p:spPr>
           <a:xfrm>
-            <a:off x="640080" y="1463040"/>
-            <a:ext cx="10908792" cy="4572000"/>
+            <a:off x="640080" y="1783080"/>
+            <a:ext cx="10908792" cy="4069080"/>
           </a:xfrm>
           <a:prstGeom prst="rect">
             <a:avLst/>
@@ -3771,8 +4239,8 @@
         </p:nvSpPr>
         <p:spPr>
           <a:xfrm>
-            <a:off x="11000232" y="6473952"/>
-            <a:ext cx="731520" cy="274320"/>
+            <a:off x="11000232" y="6181344"/>
+            <a:ext cx="731520" cy="237744"/>
           </a:xfrm>
           <a:prstGeom prst="rect">
             <a:avLst/>
@@ -3926,8 +4394,8 @@
         </p:nvSpPr>
         <p:spPr>
           <a:xfrm>
-            <a:off x="11000232" y="6473952"/>
-            <a:ext cx="731520" cy="274320"/>
+            <a:off x="11000232" y="6181344"/>
+            <a:ext cx="731520" cy="237744"/>
           </a:xfrm>
           <a:prstGeom prst="rect">
             <a:avLst/>
@@ -4040,8 +4508,8 @@
         </p:nvSpPr>
         <p:spPr>
           <a:xfrm>
-            <a:off x="11000232" y="6473952"/>
-            <a:ext cx="731520" cy="274320"/>
+            <a:off x="11000232" y="6181344"/>
+            <a:ext cx="731520" cy="237744"/>
           </a:xfrm>
           <a:prstGeom prst="rect">
             <a:avLst/>
@@ -4111,7 +4579,7 @@
         </p:nvSpPr>
         <p:spPr>
           <a:xfrm>
-            <a:off x="640080" y="457200"/>
+            <a:off x="640080" y="777240"/>
             <a:ext cx="10908792" cy="822960"/>
           </a:xfrm>
           <a:prstGeom prst="rect">
@@ -4152,8 +4620,8 @@
         </p:nvSpPr>
         <p:spPr>
           <a:xfrm>
-            <a:off x="640080" y="1463040"/>
-            <a:ext cx="10908792" cy="4572000"/>
+            <a:off x="640080" y="1783080"/>
+            <a:ext cx="10908792" cy="4069080"/>
           </a:xfrm>
           <a:prstGeom prst="rect">
             <a:avLst/>
@@ -4262,8 +4730,8 @@
         </p:nvSpPr>
         <p:spPr>
           <a:xfrm>
-            <a:off x="11000232" y="6473952"/>
-            <a:ext cx="731520" cy="274320"/>
+            <a:off x="11000232" y="6181344"/>
+            <a:ext cx="731520" cy="237744"/>
           </a:xfrm>
           <a:prstGeom prst="rect">
             <a:avLst/>
@@ -4333,7 +4801,7 @@
         </p:nvSpPr>
         <p:spPr>
           <a:xfrm>
-            <a:off x="640080" y="457200"/>
+            <a:off x="640080" y="777240"/>
             <a:ext cx="10908792" cy="822960"/>
           </a:xfrm>
           <a:prstGeom prst="rect">
@@ -4374,8 +4842,8 @@
         </p:nvSpPr>
         <p:spPr>
           <a:xfrm>
-            <a:off x="640080" y="1463040"/>
-            <a:ext cx="5212080" cy="4572000"/>
+            <a:off x="640080" y="1783080"/>
+            <a:ext cx="5212080" cy="4069080"/>
           </a:xfrm>
           <a:prstGeom prst="rect">
             <a:avLst/>
@@ -4438,8 +4906,8 @@
         </p:nvSpPr>
         <p:spPr>
           <a:xfrm>
-            <a:off x="6217920" y="1463040"/>
-            <a:ext cx="5330952" cy="4572000"/>
+            <a:off x="6217920" y="1783080"/>
+            <a:ext cx="5330952" cy="4069080"/>
           </a:xfrm>
           <a:prstGeom prst="rect">
             <a:avLst/>
@@ -4479,8 +4947,8 @@
         </p:nvSpPr>
         <p:spPr>
           <a:xfrm>
-            <a:off x="6217920" y="1463040"/>
-            <a:ext cx="5330952" cy="4572000"/>
+            <a:off x="6217920" y="1783080"/>
+            <a:ext cx="5330952" cy="4069080"/>
           </a:xfrm>
           <a:prstGeom prst="rect">
             <a:avLst/>
@@ -4511,8 +4979,8 @@
         </p:nvSpPr>
         <p:spPr>
           <a:xfrm>
-            <a:off x="11000232" y="6473952"/>
-            <a:ext cx="731520" cy="274320"/>
+            <a:off x="11000232" y="6181344"/>
+            <a:ext cx="731520" cy="237744"/>
           </a:xfrm>
           <a:prstGeom prst="rect">
             <a:avLst/>
@@ -4582,7 +5050,7 @@
         </p:nvSpPr>
         <p:spPr>
           <a:xfrm>
-            <a:off x="640080" y="457200"/>
+            <a:off x="640080" y="777240"/>
             <a:ext cx="10908792" cy="822960"/>
           </a:xfrm>
           <a:prstGeom prst="rect">
@@ -4859,8 +5327,8 @@
         </p:nvSpPr>
         <p:spPr>
           <a:xfrm>
-            <a:off x="11000232" y="6473952"/>
-            <a:ext cx="731520" cy="274320"/>
+            <a:off x="11000232" y="6181344"/>
+            <a:ext cx="731520" cy="237744"/>
           </a:xfrm>
           <a:prstGeom prst="rect">
             <a:avLst/>
@@ -5014,8 +5482,8 @@
         </p:nvSpPr>
         <p:spPr>
           <a:xfrm>
-            <a:off x="11000232" y="6473952"/>
-            <a:ext cx="731520" cy="274320"/>
+            <a:off x="11000232" y="6181344"/>
+            <a:ext cx="731520" cy="237744"/>
           </a:xfrm>
           <a:prstGeom prst="rect">
             <a:avLst/>
@@ -5169,8 +5637,8 @@
         </p:nvSpPr>
         <p:spPr>
           <a:xfrm>
-            <a:off x="11000232" y="6473952"/>
-            <a:ext cx="731520" cy="274320"/>
+            <a:off x="11000232" y="6181344"/>
+            <a:ext cx="731520" cy="237744"/>
           </a:xfrm>
           <a:prstGeom prst="rect">
             <a:avLst/>

</xml_diff>

<commit_message>
Add eXIOME acronym meaning to template header and footer (#37)
Claude-Session: https://claude.ai/code/session_01FgVjCB936DcAgdSaUcb767

Co-authored-by: Claude <noreply@anthropic.com>
</commit_message>
<xml_diff>
--- a/assets/exiome-2026-speaker-template.pptx
+++ b/assets/exiome-2026-speaker-template.pptx
@@ -114,45 +114,45 @@
   <p:extLst>
     <p:ext uri="{521415D9-36F7-43E2-AB2F-B90AF26B5E84}">
       <p14:sectionLst xmlns:p14="http://schemas.microsoft.com/office/powerpoint/2010/main">
-        <p14:section name="Instructions" id="{f346f4b9-4508-87ec-9df1-7691fcf5cde9}">
+        <p14:section name="Instructions" id="{a6e233e3-5c18-f03b-605c-a6da07d3c377}">
           <p14:sldIdLst/>
         </p14:section>
-        <p14:section name="Default-1" id="{a564d7ff-c566-890a-56b0-b3250325ec77}">
+        <p14:section name="Default-1" id="{55f826ed-b667-12a4-3e22-6b5a4e832f5c}">
           <p14:sldIdLst>
             <p14:sldId id="256"/>
           </p14:sldIdLst>
         </p14:section>
-        <p14:section name="Title" id="{c0cf977d-a13a-28d4-de48-6b266e70867f}">
+        <p14:section name="Title" id="{509cde55-3710-4764-4414-a29eb3baeac8}">
           <p14:sldIdLst>
             <p14:sldId id="257"/>
           </p14:sldIdLst>
         </p14:section>
-        <p14:section name="Section Divider" id="{28ba3ead-4113-eb58-a50a-c810e21f1d69}">
+        <p14:section name="Section Divider" id="{5b1ddb12-9423-7185-4395-9ed5f7491581}">
           <p14:sldIdLst>
             <p14:sldId id="258"/>
           </p14:sldIdLst>
         </p14:section>
-        <p14:section name="Content" id="{1832e4aa-2109-ec4a-f1a4-95c70f0b623b}">
+        <p14:section name="Content" id="{323e4035-456d-783a-1bca-4c47cf8dabd2}">
           <p14:sldIdLst>
             <p14:sldId id="259"/>
           </p14:sldIdLst>
         </p14:section>
-        <p14:section name="Content + Image" id="{914708be-8416-197b-0ad7-ccf8906ea1a3}">
+        <p14:section name="Content + Image" id="{27349f30-102b-4ea3-d6c5-3587ebf786a1}">
           <p14:sldIdLst>
             <p14:sldId id="260"/>
           </p14:sldIdLst>
         </p14:section>
-        <p14:section name="Key Figures" id="{79aa37c1-acbc-56a0-b39d-6724d28a99d4}">
+        <p14:section name="Key Figures" id="{5d5026ea-f524-d36e-0f8f-9ea2d585b8a5}">
           <p14:sldIdLst>
             <p14:sldId id="261"/>
           </p14:sldIdLst>
         </p14:section>
-        <p14:section name="Key Message" id="{a1859d23-e0a4-97be-c99a-57d5ae7fd5ce}">
+        <p14:section name="Key Message" id="{9631c843-8805-23f6-c222-d3fb2e2afb0c}">
           <p14:sldIdLst>
             <p14:sldId id="262"/>
           </p14:sldIdLst>
         </p14:section>
-        <p14:section name="Closing" id="{5ee376b9-8716-4370-c25f-31b2d2ccb70d}">
+        <p14:section name="Closing" id="{a6a4d472-c80e-7d6b-b461-aadec047632a}">
           <p14:sldIdLst>
             <p14:sldId id="263"/>
           </p14:sldIdLst>
@@ -1489,8 +1489,8 @@
         </p:nvSpPr>
         <p:spPr>
           <a:xfrm>
-            <a:off x="0" y="5852160"/>
-            <a:ext cx="12188952" cy="320040"/>
+            <a:off x="0" y="5760720"/>
+            <a:ext cx="12188952" cy="274320"/>
           </a:xfrm>
           <a:prstGeom prst="rect">
             <a:avLst/>
@@ -1536,8 +1536,8 @@
         </p:blipFill>
         <p:spPr>
           <a:xfrm>
-            <a:off x="457200" y="6291072"/>
-            <a:ext cx="1005840" cy="390094"/>
+            <a:off x="457200" y="6144768"/>
+            <a:ext cx="914400" cy="354631"/>
           </a:xfrm>
           <a:prstGeom prst="rect">
             <a:avLst/>
@@ -1552,8 +1552,8 @@
         </p:nvSpPr>
         <p:spPr>
           <a:xfrm>
-            <a:off x="457200" y="6473952"/>
-            <a:ext cx="3657600" cy="274320"/>
+            <a:off x="1508760" y="6181344"/>
+            <a:ext cx="5943600" cy="237744"/>
           </a:xfrm>
           <a:prstGeom prst="rect">
             <a:avLst/>
@@ -1569,9 +1569,9 @@
               <a:buNone/>
             </a:pPr>
             <a:r>
-              <a:rPr lang="en-US" sz="900" spc="200" kern="0" dirty="0">
-                <a:solidFill>
-                  <a:schemeClr val="accent3"/>
+              <a:rPr lang="en-US" sz="900" b="1" spc="150" kern="0" dirty="0">
+                <a:solidFill>
+                  <a:schemeClr val="accent1"/>
                 </a:solidFill>
                 <a:latin typeface="Montserrat" pitchFamily="34" charset="0"/>
                 <a:ea typeface="Montserrat" pitchFamily="34" charset="-122"/>
@@ -1580,6 +1580,45 @@
               <a:t>eXIOME 2026 · Istanbul</a:t>
             </a:r>
             <a:endParaRPr lang="en-US" sz="900" dirty="0"/>
+          </a:p>
+        </p:txBody>
+      </p:sp>
+      <p:sp>
+        <p:nvSpPr>
+          <p:cNvPr id="10" name="Text 4"/>
+          <p:cNvSpPr/>
+          <p:nvPr/>
+        </p:nvSpPr>
+        <p:spPr>
+          <a:xfrm>
+            <a:off x="1508760" y="6419088"/>
+            <a:ext cx="5943600" cy="237744"/>
+          </a:xfrm>
+          <a:prstGeom prst="rect">
+            <a:avLst/>
+          </a:prstGeom>
+          <a:noFill/>
+          <a:ln/>
+        </p:spPr>
+        <p:txBody>
+          <a:bodyPr wrap="square" lIns="0" tIns="0" rIns="0" bIns="0" rtlCol="0" anchor="ctr"/>
+          <a:lstStyle/>
+          <a:p>
+            <a:pPr algn="l" indent="0" marL="0">
+              <a:buNone/>
+            </a:pPr>
+            <a:r>
+              <a:rPr lang="en-US" sz="800" i="1" spc="50" kern="0" dirty="0">
+                <a:solidFill>
+                  <a:schemeClr val="accent3"/>
+                </a:solidFill>
+                <a:latin typeface="Montserrat" pitchFamily="34" charset="0"/>
+                <a:ea typeface="Montserrat" pitchFamily="34" charset="-122"/>
+                <a:cs typeface="Montserrat" pitchFamily="34" charset="-120"/>
+              </a:rPr>
+              <a:t>eXpert International Oncology MEeting</a:t>
+            </a:r>
+            <a:endParaRPr lang="en-US" sz="800" dirty="0"/>
           </a:p>
         </p:txBody>
       </p:sp>
@@ -1595,8 +1634,8 @@
         </p:nvSpPr>
         <p:spPr>
           <a:xfrm>
-            <a:off x="11000232" y="6473952"/>
-            <a:ext cx="731520" cy="274320"/>
+            <a:off x="11000232" y="6181344"/>
+            <a:ext cx="731520" cy="237744"/>
           </a:xfrm>
           <a:prstGeom prst="rect">
             <a:avLst/>
@@ -1755,9 +1794,48 @@
           </a:p>
         </p:txBody>
       </p:sp>
+      <p:sp>
+        <p:nvSpPr>
+          <p:cNvPr id="4" name="Text 1"/>
+          <p:cNvSpPr/>
+          <p:nvPr/>
+        </p:nvSpPr>
+        <p:spPr>
+          <a:xfrm>
+            <a:off x="640080" y="320040"/>
+            <a:ext cx="10908792" cy="274320"/>
+          </a:xfrm>
+          <a:prstGeom prst="rect">
+            <a:avLst/>
+          </a:prstGeom>
+          <a:noFill/>
+          <a:ln/>
+        </p:spPr>
+        <p:txBody>
+          <a:bodyPr wrap="square" lIns="0" tIns="0" rIns="0" bIns="0" rtlCol="0" anchor="ctr"/>
+          <a:lstStyle/>
+          <a:p>
+            <a:pPr algn="r" indent="0" marL="0">
+              <a:buNone/>
+            </a:pPr>
+            <a:r>
+              <a:rPr lang="en-US" sz="900" spc="150" kern="0" dirty="0">
+                <a:solidFill>
+                  <a:schemeClr val="accent3"/>
+                </a:solidFill>
+                <a:latin typeface="Montserrat" pitchFamily="34" charset="0"/>
+                <a:ea typeface="Montserrat" pitchFamily="34" charset="-122"/>
+                <a:cs typeface="Montserrat" pitchFamily="34" charset="-120"/>
+              </a:rPr>
+              <a:t>EXPERT INTERNATIONAL ONCOLOGY MEETING</a:t>
+            </a:r>
+            <a:endParaRPr lang="en-US" sz="900" dirty="0"/>
+          </a:p>
+        </p:txBody>
+      </p:sp>
       <p:pic>
         <p:nvPicPr>
-          <p:cNvPr id="4" name="Image 0" descr="/tmp/claude-0/-home-user/75dcd3eb-4c24-536d-ad40-f01cf5d3cf16/scratchpad/pptx-template/logo.png">    </p:cNvPr>
+          <p:cNvPr id="5" name="Image 0" descr="/tmp/claude-0/-home-user/75dcd3eb-4c24-536d-ad40-f01cf5d3cf16/scratchpad/pptx-template/logo.png">    </p:cNvPr>
           <p:cNvPicPr>
             <a:picLocks noChangeAspect="1"/>
           </p:cNvPicPr>
@@ -1771,8 +1849,8 @@
         </p:blipFill>
         <p:spPr>
           <a:xfrm>
-            <a:off x="457200" y="6291072"/>
-            <a:ext cx="1005840" cy="390094"/>
+            <a:off x="457200" y="6144768"/>
+            <a:ext cx="914400" cy="354631"/>
           </a:xfrm>
           <a:prstGeom prst="rect">
             <a:avLst/>
@@ -1781,14 +1859,14 @@
       </p:pic>
       <p:sp>
         <p:nvSpPr>
-          <p:cNvPr id="5" name="Text 1"/>
+          <p:cNvPr id="6" name="Text 2"/>
           <p:cNvSpPr/>
           <p:nvPr/>
         </p:nvSpPr>
         <p:spPr>
           <a:xfrm>
-            <a:off x="457200" y="6473952"/>
-            <a:ext cx="3657600" cy="274320"/>
+            <a:off x="1508760" y="6181344"/>
+            <a:ext cx="5943600" cy="237744"/>
           </a:xfrm>
           <a:prstGeom prst="rect">
             <a:avLst/>
@@ -1804,9 +1882,9 @@
               <a:buNone/>
             </a:pPr>
             <a:r>
-              <a:rPr lang="en-US" sz="900" spc="200" kern="0" dirty="0">
-                <a:solidFill>
-                  <a:schemeClr val="accent3"/>
+              <a:rPr lang="en-US" sz="900" b="1" spc="150" kern="0" dirty="0">
+                <a:solidFill>
+                  <a:schemeClr val="accent1"/>
                 </a:solidFill>
                 <a:latin typeface="Montserrat" pitchFamily="34" charset="0"/>
                 <a:ea typeface="Montserrat" pitchFamily="34" charset="-122"/>
@@ -1815,6 +1893,45 @@
               <a:t>eXIOME 2026 · Istanbul</a:t>
             </a:r>
             <a:endParaRPr lang="en-US" sz="900" dirty="0"/>
+          </a:p>
+        </p:txBody>
+      </p:sp>
+      <p:sp>
+        <p:nvSpPr>
+          <p:cNvPr id="7" name="Text 3"/>
+          <p:cNvSpPr/>
+          <p:nvPr/>
+        </p:nvSpPr>
+        <p:spPr>
+          <a:xfrm>
+            <a:off x="1508760" y="6419088"/>
+            <a:ext cx="5943600" cy="237744"/>
+          </a:xfrm>
+          <a:prstGeom prst="rect">
+            <a:avLst/>
+          </a:prstGeom>
+          <a:noFill/>
+          <a:ln/>
+        </p:spPr>
+        <p:txBody>
+          <a:bodyPr wrap="square" lIns="0" tIns="0" rIns="0" bIns="0" rtlCol="0" anchor="ctr"/>
+          <a:lstStyle/>
+          <a:p>
+            <a:pPr algn="l" indent="0" marL="0">
+              <a:buNone/>
+            </a:pPr>
+            <a:r>
+              <a:rPr lang="en-US" sz="800" i="1" spc="50" kern="0" dirty="0">
+                <a:solidFill>
+                  <a:schemeClr val="accent3"/>
+                </a:solidFill>
+                <a:latin typeface="Montserrat" pitchFamily="34" charset="0"/>
+                <a:ea typeface="Montserrat" pitchFamily="34" charset="-122"/>
+                <a:cs typeface="Montserrat" pitchFamily="34" charset="-120"/>
+              </a:rPr>
+              <a:t>eXpert International Oncology MEeting</a:t>
+            </a:r>
+            <a:endParaRPr lang="en-US" sz="800" dirty="0"/>
           </a:p>
         </p:txBody>
       </p:sp>
@@ -1830,8 +1947,8 @@
         </p:nvSpPr>
         <p:spPr>
           <a:xfrm>
-            <a:off x="11000232" y="6473952"/>
-            <a:ext cx="731520" cy="274320"/>
+            <a:off x="11000232" y="6181344"/>
+            <a:ext cx="731520" cy="237744"/>
           </a:xfrm>
           <a:prstGeom prst="rect">
             <a:avLst/>
@@ -1908,7 +2025,7 @@
         </p:nvSpPr>
         <p:spPr>
           <a:xfrm>
-            <a:off x="640080" y="457200"/>
+            <a:off x="640080" y="777240"/>
             <a:ext cx="10908792" cy="822960"/>
           </a:xfrm>
           <a:prstGeom prst="rect">
@@ -1961,8 +2078,8 @@
         </p:nvSpPr>
         <p:spPr>
           <a:xfrm>
-            <a:off x="640080" y="1463040"/>
-            <a:ext cx="10908792" cy="4572000"/>
+            <a:off x="640080" y="1783080"/>
+            <a:ext cx="10908792" cy="4069080"/>
           </a:xfrm>
           <a:prstGeom prst="rect">
             <a:avLst/>
@@ -2010,9 +2127,48 @@
           </a:p>
         </p:txBody>
       </p:sp>
+      <p:sp>
+        <p:nvSpPr>
+          <p:cNvPr id="4" name="Text 0"/>
+          <p:cNvSpPr/>
+          <p:nvPr/>
+        </p:nvSpPr>
+        <p:spPr>
+          <a:xfrm>
+            <a:off x="640080" y="320040"/>
+            <a:ext cx="10908792" cy="274320"/>
+          </a:xfrm>
+          <a:prstGeom prst="rect">
+            <a:avLst/>
+          </a:prstGeom>
+          <a:noFill/>
+          <a:ln/>
+        </p:spPr>
+        <p:txBody>
+          <a:bodyPr wrap="square" lIns="0" tIns="0" rIns="0" bIns="0" rtlCol="0" anchor="ctr"/>
+          <a:lstStyle/>
+          <a:p>
+            <a:pPr algn="r" indent="0" marL="0">
+              <a:buNone/>
+            </a:pPr>
+            <a:r>
+              <a:rPr lang="en-US" sz="900" spc="150" kern="0" dirty="0">
+                <a:solidFill>
+                  <a:schemeClr val="accent3"/>
+                </a:solidFill>
+                <a:latin typeface="Montserrat" pitchFamily="34" charset="0"/>
+                <a:ea typeface="Montserrat" pitchFamily="34" charset="-122"/>
+                <a:cs typeface="Montserrat" pitchFamily="34" charset="-120"/>
+              </a:rPr>
+              <a:t>EXPERT INTERNATIONAL ONCOLOGY MEETING</a:t>
+            </a:r>
+            <a:endParaRPr lang="en-US" sz="900" dirty="0"/>
+          </a:p>
+        </p:txBody>
+      </p:sp>
       <p:pic>
         <p:nvPicPr>
-          <p:cNvPr id="4" name="Image 0" descr="/tmp/claude-0/-home-user/75dcd3eb-4c24-536d-ad40-f01cf5d3cf16/scratchpad/pptx-template/logo.png">    </p:cNvPr>
+          <p:cNvPr id="5" name="Image 0" descr="/tmp/claude-0/-home-user/75dcd3eb-4c24-536d-ad40-f01cf5d3cf16/scratchpad/pptx-template/logo.png">    </p:cNvPr>
           <p:cNvPicPr>
             <a:picLocks noChangeAspect="1"/>
           </p:cNvPicPr>
@@ -2026,8 +2182,8 @@
         </p:blipFill>
         <p:spPr>
           <a:xfrm>
-            <a:off x="457200" y="6291072"/>
-            <a:ext cx="1005840" cy="390094"/>
+            <a:off x="457200" y="6144768"/>
+            <a:ext cx="914400" cy="354631"/>
           </a:xfrm>
           <a:prstGeom prst="rect">
             <a:avLst/>
@@ -2036,14 +2192,14 @@
       </p:pic>
       <p:sp>
         <p:nvSpPr>
-          <p:cNvPr id="5" name="Text 0"/>
+          <p:cNvPr id="6" name="Text 1"/>
           <p:cNvSpPr/>
           <p:nvPr/>
         </p:nvSpPr>
         <p:spPr>
           <a:xfrm>
-            <a:off x="457200" y="6473952"/>
-            <a:ext cx="3657600" cy="274320"/>
+            <a:off x="1508760" y="6181344"/>
+            <a:ext cx="5943600" cy="237744"/>
           </a:xfrm>
           <a:prstGeom prst="rect">
             <a:avLst/>
@@ -2059,9 +2215,9 @@
               <a:buNone/>
             </a:pPr>
             <a:r>
-              <a:rPr lang="en-US" sz="900" spc="200" kern="0" dirty="0">
-                <a:solidFill>
-                  <a:schemeClr val="accent3"/>
+              <a:rPr lang="en-US" sz="900" b="1" spc="150" kern="0" dirty="0">
+                <a:solidFill>
+                  <a:schemeClr val="accent1"/>
                 </a:solidFill>
                 <a:latin typeface="Montserrat" pitchFamily="34" charset="0"/>
                 <a:ea typeface="Montserrat" pitchFamily="34" charset="-122"/>
@@ -2070,6 +2226,45 @@
               <a:t>eXIOME 2026 · Istanbul</a:t>
             </a:r>
             <a:endParaRPr lang="en-US" sz="900" dirty="0"/>
+          </a:p>
+        </p:txBody>
+      </p:sp>
+      <p:sp>
+        <p:nvSpPr>
+          <p:cNvPr id="7" name="Text 2"/>
+          <p:cNvSpPr/>
+          <p:nvPr/>
+        </p:nvSpPr>
+        <p:spPr>
+          <a:xfrm>
+            <a:off x="1508760" y="6419088"/>
+            <a:ext cx="5943600" cy="237744"/>
+          </a:xfrm>
+          <a:prstGeom prst="rect">
+            <a:avLst/>
+          </a:prstGeom>
+          <a:noFill/>
+          <a:ln/>
+        </p:spPr>
+        <p:txBody>
+          <a:bodyPr wrap="square" lIns="0" tIns="0" rIns="0" bIns="0" rtlCol="0" anchor="ctr"/>
+          <a:lstStyle/>
+          <a:p>
+            <a:pPr algn="l" indent="0" marL="0">
+              <a:buNone/>
+            </a:pPr>
+            <a:r>
+              <a:rPr lang="en-US" sz="800" i="1" spc="50" kern="0" dirty="0">
+                <a:solidFill>
+                  <a:schemeClr val="accent3"/>
+                </a:solidFill>
+                <a:latin typeface="Montserrat" pitchFamily="34" charset="0"/>
+                <a:ea typeface="Montserrat" pitchFamily="34" charset="-122"/>
+                <a:cs typeface="Montserrat" pitchFamily="34" charset="-120"/>
+              </a:rPr>
+              <a:t>eXpert International Oncology MEeting</a:t>
+            </a:r>
+            <a:endParaRPr lang="en-US" sz="800" dirty="0"/>
           </a:p>
         </p:txBody>
       </p:sp>
@@ -2085,8 +2280,8 @@
         </p:nvSpPr>
         <p:spPr>
           <a:xfrm>
-            <a:off x="11000232" y="6473952"/>
-            <a:ext cx="731520" cy="274320"/>
+            <a:off x="11000232" y="6181344"/>
+            <a:ext cx="731520" cy="237744"/>
           </a:xfrm>
           <a:prstGeom prst="rect">
             <a:avLst/>
@@ -2163,7 +2358,7 @@
         </p:nvSpPr>
         <p:spPr>
           <a:xfrm>
-            <a:off x="640080" y="457200"/>
+            <a:off x="640080" y="777240"/>
             <a:ext cx="10908792" cy="822960"/>
           </a:xfrm>
           <a:prstGeom prst="rect">
@@ -2216,8 +2411,8 @@
         </p:nvSpPr>
         <p:spPr>
           <a:xfrm>
-            <a:off x="640080" y="1463040"/>
-            <a:ext cx="5212080" cy="4572000"/>
+            <a:off x="640080" y="1783080"/>
+            <a:ext cx="5212080" cy="4069080"/>
           </a:xfrm>
           <a:prstGeom prst="rect">
             <a:avLst/>
@@ -2273,8 +2468,8 @@
         </p:nvSpPr>
         <p:spPr>
           <a:xfrm>
-            <a:off x="6217920" y="1463040"/>
-            <a:ext cx="5330952" cy="4572000"/>
+            <a:off x="6217920" y="1783080"/>
+            <a:ext cx="5330952" cy="4069080"/>
           </a:xfrm>
           <a:prstGeom prst="rect">
             <a:avLst/>
@@ -2300,8 +2495,8 @@
         </p:nvSpPr>
         <p:spPr>
           <a:xfrm>
-            <a:off x="6217920" y="1463040"/>
-            <a:ext cx="5330952" cy="4572000"/>
+            <a:off x="6217920" y="1783080"/>
+            <a:ext cx="5330952" cy="4069080"/>
           </a:xfrm>
           <a:prstGeom prst="rect">
             <a:avLst/>
@@ -2325,9 +2520,48 @@
           </a:p>
         </p:txBody>
       </p:sp>
+      <p:sp>
+        <p:nvSpPr>
+          <p:cNvPr id="6" name="Text 1"/>
+          <p:cNvSpPr/>
+          <p:nvPr/>
+        </p:nvSpPr>
+        <p:spPr>
+          <a:xfrm>
+            <a:off x="640080" y="320040"/>
+            <a:ext cx="10908792" cy="274320"/>
+          </a:xfrm>
+          <a:prstGeom prst="rect">
+            <a:avLst/>
+          </a:prstGeom>
+          <a:noFill/>
+          <a:ln/>
+        </p:spPr>
+        <p:txBody>
+          <a:bodyPr wrap="square" lIns="0" tIns="0" rIns="0" bIns="0" rtlCol="0" anchor="ctr"/>
+          <a:lstStyle/>
+          <a:p>
+            <a:pPr algn="r" indent="0" marL="0">
+              <a:buNone/>
+            </a:pPr>
+            <a:r>
+              <a:rPr lang="en-US" sz="900" spc="150" kern="0" dirty="0">
+                <a:solidFill>
+                  <a:schemeClr val="accent3"/>
+                </a:solidFill>
+                <a:latin typeface="Montserrat" pitchFamily="34" charset="0"/>
+                <a:ea typeface="Montserrat" pitchFamily="34" charset="-122"/>
+                <a:cs typeface="Montserrat" pitchFamily="34" charset="-120"/>
+              </a:rPr>
+              <a:t>EXPERT INTERNATIONAL ONCOLOGY MEETING</a:t>
+            </a:r>
+            <a:endParaRPr lang="en-US" sz="900" dirty="0"/>
+          </a:p>
+        </p:txBody>
+      </p:sp>
       <p:pic>
         <p:nvPicPr>
-          <p:cNvPr id="6" name="Image 0" descr="/tmp/claude-0/-home-user/75dcd3eb-4c24-536d-ad40-f01cf5d3cf16/scratchpad/pptx-template/logo.png">    </p:cNvPr>
+          <p:cNvPr id="7" name="Image 0" descr="/tmp/claude-0/-home-user/75dcd3eb-4c24-536d-ad40-f01cf5d3cf16/scratchpad/pptx-template/logo.png">    </p:cNvPr>
           <p:cNvPicPr>
             <a:picLocks noChangeAspect="1"/>
           </p:cNvPicPr>
@@ -2341,8 +2575,8 @@
         </p:blipFill>
         <p:spPr>
           <a:xfrm>
-            <a:off x="457200" y="6291072"/>
-            <a:ext cx="1005840" cy="390094"/>
+            <a:off x="457200" y="6144768"/>
+            <a:ext cx="914400" cy="354631"/>
           </a:xfrm>
           <a:prstGeom prst="rect">
             <a:avLst/>
@@ -2351,14 +2585,14 @@
       </p:pic>
       <p:sp>
         <p:nvSpPr>
-          <p:cNvPr id="7" name="Text 1"/>
+          <p:cNvPr id="8" name="Text 2"/>
           <p:cNvSpPr/>
           <p:nvPr/>
         </p:nvSpPr>
         <p:spPr>
           <a:xfrm>
-            <a:off x="457200" y="6473952"/>
-            <a:ext cx="3657600" cy="274320"/>
+            <a:off x="1508760" y="6181344"/>
+            <a:ext cx="5943600" cy="237744"/>
           </a:xfrm>
           <a:prstGeom prst="rect">
             <a:avLst/>
@@ -2374,9 +2608,9 @@
               <a:buNone/>
             </a:pPr>
             <a:r>
-              <a:rPr lang="en-US" sz="900" spc="200" kern="0" dirty="0">
-                <a:solidFill>
-                  <a:schemeClr val="accent3"/>
+              <a:rPr lang="en-US" sz="900" b="1" spc="150" kern="0" dirty="0">
+                <a:solidFill>
+                  <a:schemeClr val="accent1"/>
                 </a:solidFill>
                 <a:latin typeface="Montserrat" pitchFamily="34" charset="0"/>
                 <a:ea typeface="Montserrat" pitchFamily="34" charset="-122"/>
@@ -2385,6 +2619,45 @@
               <a:t>eXIOME 2026 · Istanbul</a:t>
             </a:r>
             <a:endParaRPr lang="en-US" sz="900" dirty="0"/>
+          </a:p>
+        </p:txBody>
+      </p:sp>
+      <p:sp>
+        <p:nvSpPr>
+          <p:cNvPr id="9" name="Text 3"/>
+          <p:cNvSpPr/>
+          <p:nvPr/>
+        </p:nvSpPr>
+        <p:spPr>
+          <a:xfrm>
+            <a:off x="1508760" y="6419088"/>
+            <a:ext cx="5943600" cy="237744"/>
+          </a:xfrm>
+          <a:prstGeom prst="rect">
+            <a:avLst/>
+          </a:prstGeom>
+          <a:noFill/>
+          <a:ln/>
+        </p:spPr>
+        <p:txBody>
+          <a:bodyPr wrap="square" lIns="0" tIns="0" rIns="0" bIns="0" rtlCol="0" anchor="ctr"/>
+          <a:lstStyle/>
+          <a:p>
+            <a:pPr algn="l" indent="0" marL="0">
+              <a:buNone/>
+            </a:pPr>
+            <a:r>
+              <a:rPr lang="en-US" sz="800" i="1" spc="50" kern="0" dirty="0">
+                <a:solidFill>
+                  <a:schemeClr val="accent3"/>
+                </a:solidFill>
+                <a:latin typeface="Montserrat" pitchFamily="34" charset="0"/>
+                <a:ea typeface="Montserrat" pitchFamily="34" charset="-122"/>
+                <a:cs typeface="Montserrat" pitchFamily="34" charset="-120"/>
+              </a:rPr>
+              <a:t>eXpert International Oncology MEeting</a:t>
+            </a:r>
+            <a:endParaRPr lang="en-US" sz="800" dirty="0"/>
           </a:p>
         </p:txBody>
       </p:sp>
@@ -2400,8 +2673,8 @@
         </p:nvSpPr>
         <p:spPr>
           <a:xfrm>
-            <a:off x="11000232" y="6473952"/>
-            <a:ext cx="731520" cy="274320"/>
+            <a:off x="11000232" y="6181344"/>
+            <a:ext cx="731520" cy="237744"/>
           </a:xfrm>
           <a:prstGeom prst="rect">
             <a:avLst/>
@@ -2478,7 +2751,7 @@
         </p:nvSpPr>
         <p:spPr>
           <a:xfrm>
-            <a:off x="640080" y="457200"/>
+            <a:off x="640080" y="777240"/>
             <a:ext cx="10908792" cy="822960"/>
           </a:xfrm>
           <a:prstGeom prst="rect">
@@ -2521,9 +2794,48 @@
           </a:p>
         </p:txBody>
       </p:sp>
+      <p:sp>
+        <p:nvSpPr>
+          <p:cNvPr id="3" name="Text 0"/>
+          <p:cNvSpPr/>
+          <p:nvPr/>
+        </p:nvSpPr>
+        <p:spPr>
+          <a:xfrm>
+            <a:off x="640080" y="320040"/>
+            <a:ext cx="10908792" cy="274320"/>
+          </a:xfrm>
+          <a:prstGeom prst="rect">
+            <a:avLst/>
+          </a:prstGeom>
+          <a:noFill/>
+          <a:ln/>
+        </p:spPr>
+        <p:txBody>
+          <a:bodyPr wrap="square" lIns="0" tIns="0" rIns="0" bIns="0" rtlCol="0" anchor="ctr"/>
+          <a:lstStyle/>
+          <a:p>
+            <a:pPr algn="r" indent="0" marL="0">
+              <a:buNone/>
+            </a:pPr>
+            <a:r>
+              <a:rPr lang="en-US" sz="900" spc="150" kern="0" dirty="0">
+                <a:solidFill>
+                  <a:schemeClr val="accent3"/>
+                </a:solidFill>
+                <a:latin typeface="Montserrat" pitchFamily="34" charset="0"/>
+                <a:ea typeface="Montserrat" pitchFamily="34" charset="-122"/>
+                <a:cs typeface="Montserrat" pitchFamily="34" charset="-120"/>
+              </a:rPr>
+              <a:t>EXPERT INTERNATIONAL ONCOLOGY MEETING</a:t>
+            </a:r>
+            <a:endParaRPr lang="en-US" sz="900" dirty="0"/>
+          </a:p>
+        </p:txBody>
+      </p:sp>
       <p:pic>
         <p:nvPicPr>
-          <p:cNvPr id="3" name="Image 0" descr="/tmp/claude-0/-home-user/75dcd3eb-4c24-536d-ad40-f01cf5d3cf16/scratchpad/pptx-template/logo.png">    </p:cNvPr>
+          <p:cNvPr id="4" name="Image 0" descr="/tmp/claude-0/-home-user/75dcd3eb-4c24-536d-ad40-f01cf5d3cf16/scratchpad/pptx-template/logo.png">    </p:cNvPr>
           <p:cNvPicPr>
             <a:picLocks noChangeAspect="1"/>
           </p:cNvPicPr>
@@ -2537,8 +2849,8 @@
         </p:blipFill>
         <p:spPr>
           <a:xfrm>
-            <a:off x="457200" y="6291072"/>
-            <a:ext cx="1005840" cy="390094"/>
+            <a:off x="457200" y="6144768"/>
+            <a:ext cx="914400" cy="354631"/>
           </a:xfrm>
           <a:prstGeom prst="rect">
             <a:avLst/>
@@ -2547,14 +2859,14 @@
       </p:pic>
       <p:sp>
         <p:nvSpPr>
-          <p:cNvPr id="4" name="Text 0"/>
+          <p:cNvPr id="5" name="Text 1"/>
           <p:cNvSpPr/>
           <p:nvPr/>
         </p:nvSpPr>
         <p:spPr>
           <a:xfrm>
-            <a:off x="457200" y="6473952"/>
-            <a:ext cx="3657600" cy="274320"/>
+            <a:off x="1508760" y="6181344"/>
+            <a:ext cx="5943600" cy="237744"/>
           </a:xfrm>
           <a:prstGeom prst="rect">
             <a:avLst/>
@@ -2570,9 +2882,9 @@
               <a:buNone/>
             </a:pPr>
             <a:r>
-              <a:rPr lang="en-US" sz="900" spc="200" kern="0" dirty="0">
-                <a:solidFill>
-                  <a:schemeClr val="accent3"/>
+              <a:rPr lang="en-US" sz="900" b="1" spc="150" kern="0" dirty="0">
+                <a:solidFill>
+                  <a:schemeClr val="accent1"/>
                 </a:solidFill>
                 <a:latin typeface="Montserrat" pitchFamily="34" charset="0"/>
                 <a:ea typeface="Montserrat" pitchFamily="34" charset="-122"/>
@@ -2581,6 +2893,45 @@
               <a:t>eXIOME 2026 · Istanbul</a:t>
             </a:r>
             <a:endParaRPr lang="en-US" sz="900" dirty="0"/>
+          </a:p>
+        </p:txBody>
+      </p:sp>
+      <p:sp>
+        <p:nvSpPr>
+          <p:cNvPr id="6" name="Text 2"/>
+          <p:cNvSpPr/>
+          <p:nvPr/>
+        </p:nvSpPr>
+        <p:spPr>
+          <a:xfrm>
+            <a:off x="1508760" y="6419088"/>
+            <a:ext cx="5943600" cy="237744"/>
+          </a:xfrm>
+          <a:prstGeom prst="rect">
+            <a:avLst/>
+          </a:prstGeom>
+          <a:noFill/>
+          <a:ln/>
+        </p:spPr>
+        <p:txBody>
+          <a:bodyPr wrap="square" lIns="0" tIns="0" rIns="0" bIns="0" rtlCol="0" anchor="ctr"/>
+          <a:lstStyle/>
+          <a:p>
+            <a:pPr algn="l" indent="0" marL="0">
+              <a:buNone/>
+            </a:pPr>
+            <a:r>
+              <a:rPr lang="en-US" sz="800" i="1" spc="50" kern="0" dirty="0">
+                <a:solidFill>
+                  <a:schemeClr val="accent3"/>
+                </a:solidFill>
+                <a:latin typeface="Montserrat" pitchFamily="34" charset="0"/>
+                <a:ea typeface="Montserrat" pitchFamily="34" charset="-122"/>
+                <a:cs typeface="Montserrat" pitchFamily="34" charset="-120"/>
+              </a:rPr>
+              <a:t>eXpert International Oncology MEeting</a:t>
+            </a:r>
+            <a:endParaRPr lang="en-US" sz="800" dirty="0"/>
           </a:p>
         </p:txBody>
       </p:sp>
@@ -2596,8 +2947,8 @@
         </p:nvSpPr>
         <p:spPr>
           <a:xfrm>
-            <a:off x="11000232" y="6473952"/>
-            <a:ext cx="731520" cy="274320"/>
+            <a:off x="11000232" y="6181344"/>
+            <a:ext cx="731520" cy="237744"/>
           </a:xfrm>
           <a:prstGeom prst="rect">
             <a:avLst/>
@@ -2809,9 +3160,48 @@
           </a:p>
         </p:txBody>
       </p:sp>
+      <p:sp>
+        <p:nvSpPr>
+          <p:cNvPr id="5" name="Text 1"/>
+          <p:cNvSpPr/>
+          <p:nvPr/>
+        </p:nvSpPr>
+        <p:spPr>
+          <a:xfrm>
+            <a:off x="640080" y="320040"/>
+            <a:ext cx="10908792" cy="274320"/>
+          </a:xfrm>
+          <a:prstGeom prst="rect">
+            <a:avLst/>
+          </a:prstGeom>
+          <a:noFill/>
+          <a:ln/>
+        </p:spPr>
+        <p:txBody>
+          <a:bodyPr wrap="square" lIns="0" tIns="0" rIns="0" bIns="0" rtlCol="0" anchor="ctr"/>
+          <a:lstStyle/>
+          <a:p>
+            <a:pPr algn="r" indent="0" marL="0">
+              <a:buNone/>
+            </a:pPr>
+            <a:r>
+              <a:rPr lang="en-US" sz="900" spc="150" kern="0" dirty="0">
+                <a:solidFill>
+                  <a:schemeClr val="accent3"/>
+                </a:solidFill>
+                <a:latin typeface="Montserrat" pitchFamily="34" charset="0"/>
+                <a:ea typeface="Montserrat" pitchFamily="34" charset="-122"/>
+                <a:cs typeface="Montserrat" pitchFamily="34" charset="-120"/>
+              </a:rPr>
+              <a:t>EXPERT INTERNATIONAL ONCOLOGY MEETING</a:t>
+            </a:r>
+            <a:endParaRPr lang="en-US" sz="900" dirty="0"/>
+          </a:p>
+        </p:txBody>
+      </p:sp>
       <p:pic>
         <p:nvPicPr>
-          <p:cNvPr id="5" name="Image 0" descr="/tmp/claude-0/-home-user/75dcd3eb-4c24-536d-ad40-f01cf5d3cf16/scratchpad/pptx-template/logo.png">    </p:cNvPr>
+          <p:cNvPr id="6" name="Image 0" descr="/tmp/claude-0/-home-user/75dcd3eb-4c24-536d-ad40-f01cf5d3cf16/scratchpad/pptx-template/logo.png">    </p:cNvPr>
           <p:cNvPicPr>
             <a:picLocks noChangeAspect="1"/>
           </p:cNvPicPr>
@@ -2825,8 +3215,8 @@
         </p:blipFill>
         <p:spPr>
           <a:xfrm>
-            <a:off x="457200" y="6291072"/>
-            <a:ext cx="1005840" cy="390094"/>
+            <a:off x="457200" y="6144768"/>
+            <a:ext cx="914400" cy="354631"/>
           </a:xfrm>
           <a:prstGeom prst="rect">
             <a:avLst/>
@@ -2835,14 +3225,14 @@
       </p:pic>
       <p:sp>
         <p:nvSpPr>
-          <p:cNvPr id="6" name="Text 1"/>
+          <p:cNvPr id="7" name="Text 2"/>
           <p:cNvSpPr/>
           <p:nvPr/>
         </p:nvSpPr>
         <p:spPr>
           <a:xfrm>
-            <a:off x="457200" y="6473952"/>
-            <a:ext cx="3657600" cy="274320"/>
+            <a:off x="1508760" y="6181344"/>
+            <a:ext cx="5943600" cy="237744"/>
           </a:xfrm>
           <a:prstGeom prst="rect">
             <a:avLst/>
@@ -2858,9 +3248,9 @@
               <a:buNone/>
             </a:pPr>
             <a:r>
-              <a:rPr lang="en-US" sz="900" spc="200" kern="0" dirty="0">
-                <a:solidFill>
-                  <a:schemeClr val="accent3"/>
+              <a:rPr lang="en-US" sz="900" b="1" spc="150" kern="0" dirty="0">
+                <a:solidFill>
+                  <a:schemeClr val="accent1"/>
                 </a:solidFill>
                 <a:latin typeface="Montserrat" pitchFamily="34" charset="0"/>
                 <a:ea typeface="Montserrat" pitchFamily="34" charset="-122"/>
@@ -2869,6 +3259,45 @@
               <a:t>eXIOME 2026 · Istanbul</a:t>
             </a:r>
             <a:endParaRPr lang="en-US" sz="900" dirty="0"/>
+          </a:p>
+        </p:txBody>
+      </p:sp>
+      <p:sp>
+        <p:nvSpPr>
+          <p:cNvPr id="8" name="Text 3"/>
+          <p:cNvSpPr/>
+          <p:nvPr/>
+        </p:nvSpPr>
+        <p:spPr>
+          <a:xfrm>
+            <a:off x="1508760" y="6419088"/>
+            <a:ext cx="5943600" cy="237744"/>
+          </a:xfrm>
+          <a:prstGeom prst="rect">
+            <a:avLst/>
+          </a:prstGeom>
+          <a:noFill/>
+          <a:ln/>
+        </p:spPr>
+        <p:txBody>
+          <a:bodyPr wrap="square" lIns="0" tIns="0" rIns="0" bIns="0" rtlCol="0" anchor="ctr"/>
+          <a:lstStyle/>
+          <a:p>
+            <a:pPr algn="l" indent="0" marL="0">
+              <a:buNone/>
+            </a:pPr>
+            <a:r>
+              <a:rPr lang="en-US" sz="800" i="1" spc="50" kern="0" dirty="0">
+                <a:solidFill>
+                  <a:schemeClr val="accent3"/>
+                </a:solidFill>
+                <a:latin typeface="Montserrat" pitchFamily="34" charset="0"/>
+                <a:ea typeface="Montserrat" pitchFamily="34" charset="-122"/>
+                <a:cs typeface="Montserrat" pitchFamily="34" charset="-120"/>
+              </a:rPr>
+              <a:t>eXpert International Oncology MEeting</a:t>
+            </a:r>
+            <a:endParaRPr lang="en-US" sz="800" dirty="0"/>
           </a:p>
         </p:txBody>
       </p:sp>
@@ -2884,8 +3313,8 @@
         </p:nvSpPr>
         <p:spPr>
           <a:xfrm>
-            <a:off x="11000232" y="6473952"/>
-            <a:ext cx="731520" cy="274320"/>
+            <a:off x="11000232" y="6181344"/>
+            <a:ext cx="731520" cy="237744"/>
           </a:xfrm>
           <a:prstGeom prst="rect">
             <a:avLst/>
@@ -3137,8 +3566,8 @@
         </p:blipFill>
         <p:spPr>
           <a:xfrm>
-            <a:off x="457200" y="6291072"/>
-            <a:ext cx="1005840" cy="390094"/>
+            <a:off x="457200" y="6144768"/>
+            <a:ext cx="914400" cy="354631"/>
           </a:xfrm>
           <a:prstGeom prst="rect">
             <a:avLst/>
@@ -3153,8 +3582,8 @@
         </p:nvSpPr>
         <p:spPr>
           <a:xfrm>
-            <a:off x="457200" y="6473952"/>
-            <a:ext cx="3657600" cy="274320"/>
+            <a:off x="1508760" y="6181344"/>
+            <a:ext cx="5943600" cy="237744"/>
           </a:xfrm>
           <a:prstGeom prst="rect">
             <a:avLst/>
@@ -3170,9 +3599,9 @@
               <a:buNone/>
             </a:pPr>
             <a:r>
-              <a:rPr lang="en-US" sz="900" spc="200" kern="0" dirty="0">
-                <a:solidFill>
-                  <a:schemeClr val="accent3"/>
+              <a:rPr lang="en-US" sz="900" b="1" spc="150" kern="0" dirty="0">
+                <a:solidFill>
+                  <a:schemeClr val="accent1"/>
                 </a:solidFill>
                 <a:latin typeface="Montserrat" pitchFamily="34" charset="0"/>
                 <a:ea typeface="Montserrat" pitchFamily="34" charset="-122"/>
@@ -3181,6 +3610,45 @@
               <a:t>eXIOME 2026 · Istanbul</a:t>
             </a:r>
             <a:endParaRPr lang="en-US" sz="900" dirty="0"/>
+          </a:p>
+        </p:txBody>
+      </p:sp>
+      <p:sp>
+        <p:nvSpPr>
+          <p:cNvPr id="8" name="Text 2"/>
+          <p:cNvSpPr/>
+          <p:nvPr/>
+        </p:nvSpPr>
+        <p:spPr>
+          <a:xfrm>
+            <a:off x="1508760" y="6419088"/>
+            <a:ext cx="5943600" cy="237744"/>
+          </a:xfrm>
+          <a:prstGeom prst="rect">
+            <a:avLst/>
+          </a:prstGeom>
+          <a:noFill/>
+          <a:ln/>
+        </p:spPr>
+        <p:txBody>
+          <a:bodyPr wrap="square" lIns="0" tIns="0" rIns="0" bIns="0" rtlCol="0" anchor="ctr"/>
+          <a:lstStyle/>
+          <a:p>
+            <a:pPr algn="l" indent="0" marL="0">
+              <a:buNone/>
+            </a:pPr>
+            <a:r>
+              <a:rPr lang="en-US" sz="800" i="1" spc="50" kern="0" dirty="0">
+                <a:solidFill>
+                  <a:schemeClr val="accent3"/>
+                </a:solidFill>
+                <a:latin typeface="Montserrat" pitchFamily="34" charset="0"/>
+                <a:ea typeface="Montserrat" pitchFamily="34" charset="-122"/>
+                <a:cs typeface="Montserrat" pitchFamily="34" charset="-120"/>
+              </a:rPr>
+              <a:t>eXpert International Oncology MEeting</a:t>
+            </a:r>
+            <a:endParaRPr lang="en-US" sz="800" dirty="0"/>
           </a:p>
         </p:txBody>
       </p:sp>
@@ -3196,8 +3664,8 @@
         </p:nvSpPr>
         <p:spPr>
           <a:xfrm>
-            <a:off x="11000232" y="6473952"/>
-            <a:ext cx="731520" cy="274320"/>
+            <a:off x="11000232" y="6181344"/>
+            <a:ext cx="731520" cy="237744"/>
           </a:xfrm>
           <a:prstGeom prst="rect">
             <a:avLst/>
@@ -3269,8 +3737,8 @@
         </p:nvSpPr>
         <p:spPr>
           <a:xfrm>
-            <a:off x="11000232" y="6473952"/>
-            <a:ext cx="731520" cy="274320"/>
+            <a:off x="11000232" y="6181344"/>
+            <a:ext cx="731520" cy="237744"/>
           </a:xfrm>
           <a:prstGeom prst="rect">
             <a:avLst/>
@@ -3599,7 +4067,7 @@
         </p:nvSpPr>
         <p:spPr>
           <a:xfrm>
-            <a:off x="640080" y="457200"/>
+            <a:off x="640080" y="777240"/>
             <a:ext cx="10908792" cy="822960"/>
           </a:xfrm>
           <a:prstGeom prst="rect">
@@ -3640,8 +4108,8 @@
         </p:nvSpPr>
         <p:spPr>
           <a:xfrm>
-            <a:off x="640080" y="1463040"/>
-            <a:ext cx="10908792" cy="4572000"/>
+            <a:off x="640080" y="1783080"/>
+            <a:ext cx="10908792" cy="4069080"/>
           </a:xfrm>
           <a:prstGeom prst="rect">
             <a:avLst/>
@@ -3771,8 +4239,8 @@
         </p:nvSpPr>
         <p:spPr>
           <a:xfrm>
-            <a:off x="11000232" y="6473952"/>
-            <a:ext cx="731520" cy="274320"/>
+            <a:off x="11000232" y="6181344"/>
+            <a:ext cx="731520" cy="237744"/>
           </a:xfrm>
           <a:prstGeom prst="rect">
             <a:avLst/>
@@ -3926,8 +4394,8 @@
         </p:nvSpPr>
         <p:spPr>
           <a:xfrm>
-            <a:off x="11000232" y="6473952"/>
-            <a:ext cx="731520" cy="274320"/>
+            <a:off x="11000232" y="6181344"/>
+            <a:ext cx="731520" cy="237744"/>
           </a:xfrm>
           <a:prstGeom prst="rect">
             <a:avLst/>
@@ -4040,8 +4508,8 @@
         </p:nvSpPr>
         <p:spPr>
           <a:xfrm>
-            <a:off x="11000232" y="6473952"/>
-            <a:ext cx="731520" cy="274320"/>
+            <a:off x="11000232" y="6181344"/>
+            <a:ext cx="731520" cy="237744"/>
           </a:xfrm>
           <a:prstGeom prst="rect">
             <a:avLst/>
@@ -4111,7 +4579,7 @@
         </p:nvSpPr>
         <p:spPr>
           <a:xfrm>
-            <a:off x="640080" y="457200"/>
+            <a:off x="640080" y="777240"/>
             <a:ext cx="10908792" cy="822960"/>
           </a:xfrm>
           <a:prstGeom prst="rect">
@@ -4152,8 +4620,8 @@
         </p:nvSpPr>
         <p:spPr>
           <a:xfrm>
-            <a:off x="640080" y="1463040"/>
-            <a:ext cx="10908792" cy="4572000"/>
+            <a:off x="640080" y="1783080"/>
+            <a:ext cx="10908792" cy="4069080"/>
           </a:xfrm>
           <a:prstGeom prst="rect">
             <a:avLst/>
@@ -4262,8 +4730,8 @@
         </p:nvSpPr>
         <p:spPr>
           <a:xfrm>
-            <a:off x="11000232" y="6473952"/>
-            <a:ext cx="731520" cy="274320"/>
+            <a:off x="11000232" y="6181344"/>
+            <a:ext cx="731520" cy="237744"/>
           </a:xfrm>
           <a:prstGeom prst="rect">
             <a:avLst/>
@@ -4333,7 +4801,7 @@
         </p:nvSpPr>
         <p:spPr>
           <a:xfrm>
-            <a:off x="640080" y="457200"/>
+            <a:off x="640080" y="777240"/>
             <a:ext cx="10908792" cy="822960"/>
           </a:xfrm>
           <a:prstGeom prst="rect">
@@ -4374,8 +4842,8 @@
         </p:nvSpPr>
         <p:spPr>
           <a:xfrm>
-            <a:off x="640080" y="1463040"/>
-            <a:ext cx="5212080" cy="4572000"/>
+            <a:off x="640080" y="1783080"/>
+            <a:ext cx="5212080" cy="4069080"/>
           </a:xfrm>
           <a:prstGeom prst="rect">
             <a:avLst/>
@@ -4438,8 +4906,8 @@
         </p:nvSpPr>
         <p:spPr>
           <a:xfrm>
-            <a:off x="6217920" y="1463040"/>
-            <a:ext cx="5330952" cy="4572000"/>
+            <a:off x="6217920" y="1783080"/>
+            <a:ext cx="5330952" cy="4069080"/>
           </a:xfrm>
           <a:prstGeom prst="rect">
             <a:avLst/>
@@ -4479,8 +4947,8 @@
         </p:nvSpPr>
         <p:spPr>
           <a:xfrm>
-            <a:off x="6217920" y="1463040"/>
-            <a:ext cx="5330952" cy="4572000"/>
+            <a:off x="6217920" y="1783080"/>
+            <a:ext cx="5330952" cy="4069080"/>
           </a:xfrm>
           <a:prstGeom prst="rect">
             <a:avLst/>
@@ -4511,8 +4979,8 @@
         </p:nvSpPr>
         <p:spPr>
           <a:xfrm>
-            <a:off x="11000232" y="6473952"/>
-            <a:ext cx="731520" cy="274320"/>
+            <a:off x="11000232" y="6181344"/>
+            <a:ext cx="731520" cy="237744"/>
           </a:xfrm>
           <a:prstGeom prst="rect">
             <a:avLst/>
@@ -4582,7 +5050,7 @@
         </p:nvSpPr>
         <p:spPr>
           <a:xfrm>
-            <a:off x="640080" y="457200"/>
+            <a:off x="640080" y="777240"/>
             <a:ext cx="10908792" cy="822960"/>
           </a:xfrm>
           <a:prstGeom prst="rect">
@@ -4859,8 +5327,8 @@
         </p:nvSpPr>
         <p:spPr>
           <a:xfrm>
-            <a:off x="11000232" y="6473952"/>
-            <a:ext cx="731520" cy="274320"/>
+            <a:off x="11000232" y="6181344"/>
+            <a:ext cx="731520" cy="237744"/>
           </a:xfrm>
           <a:prstGeom prst="rect">
             <a:avLst/>
@@ -5014,8 +5482,8 @@
         </p:nvSpPr>
         <p:spPr>
           <a:xfrm>
-            <a:off x="11000232" y="6473952"/>
-            <a:ext cx="731520" cy="274320"/>
+            <a:off x="11000232" y="6181344"/>
+            <a:ext cx="731520" cy="237744"/>
           </a:xfrm>
           <a:prstGeom prst="rect">
             <a:avLst/>
@@ -5169,8 +5637,8 @@
         </p:nvSpPr>
         <p:spPr>
           <a:xfrm>
-            <a:off x="11000232" y="6473952"/>
-            <a:ext cx="731520" cy="274320"/>
+            <a:off x="11000232" y="6181344"/>
+            <a:ext cx="731520" cy="237744"/>
           </a:xfrm>
           <a:prstGeom prst="rect">
             <a:avLst/>

</xml_diff>